<commit_message>
refactor: reusable make_ppt.py at root, rename questions, new 8-slide PPT structure
Co-authored-by: Cursor <cursoragent@cursor.com>
</commit_message>
<xml_diff>
--- a/presentation.pptx
+++ b/presentation.pptx
@@ -14,13 +14,6 @@
     <p:sldId id="262" r:id="rId13"/>
     <p:sldId id="263" r:id="rId14"/>
     <p:sldId id="264" r:id="rId15"/>
-    <p:sldId id="265" r:id="rId16"/>
-    <p:sldId id="266" r:id="rId17"/>
-    <p:sldId id="267" r:id="rId18"/>
-    <p:sldId id="268" r:id="rId19"/>
-    <p:sldId id="269" r:id="rId20"/>
-    <p:sldId id="270" r:id="rId21"/>
-    <p:sldId id="271" r:id="rId22"/>
   </p:sldIdLst>
   <p:sldSz cx="12191695" cy="6858000" type="screen4x3"/>
   <p:notesSz cx="6858000" cy="9144000"/>
@@ -3120,7 +3113,7 @@
         <p:spPr>
           <a:xfrm>
             <a:off x="914400" y="1371600"/>
-            <a:ext cx="10058400" cy="2743200"/>
+            <a:ext cx="10058400" cy="3657600"/>
           </a:xfrm>
           <a:prstGeom prst="rect">
             <a:avLst/>
@@ -3154,7 +3147,7 @@
               </a:defRPr>
             </a:pPr>
             <a:r>
-              <a:t>Git 기반 협업 &amp; 픽셀 단위 이미지 처리</a:t>
+              <a:t>Git을 활용한 코드 관리 및 픽셀 단위 이미지 처리 실습</a:t>
             </a:r>
           </a:p>
           <a:p>
@@ -3168,7 +3161,7 @@
           </a:p>
           <a:p>
             <a:pPr>
-              <a:defRPr sz="1800" b="0">
+              <a:defRPr sz="1600" b="0">
                 <a:solidFill>
                   <a:srgbClr val="999999"/>
                 </a:solidFill>
@@ -3180,7 +3173,7 @@
           </a:p>
           <a:p>
             <a:pPr>
-              <a:defRPr sz="1800" b="0">
+              <a:defRPr sz="1600" b="0">
                 <a:solidFill>
                   <a:srgbClr val="999999"/>
                 </a:solidFill>
@@ -3188,1421 +3181,6 @@
             </a:pPr>
             <a:r>
               <a:t>베어곰 멘토  |  2026.07</a:t>
-            </a:r>
-          </a:p>
-        </p:txBody>
-      </p:sp>
-    </p:spTree>
-  </p:cSld>
-  <p:clrMapOvr>
-    <a:masterClrMapping/>
-  </p:clrMapOvr>
-</p:sld>
-</file>
-
-<file path=ppt/slides/slide10.xml><?xml version="1.0" encoding="utf-8"?>
-<p:sld xmlns:a="http://schemas.openxmlformats.org/drawingml/2006/main" xmlns:p="http://schemas.openxmlformats.org/presentationml/2006/main" xmlns:r="http://schemas.openxmlformats.org/officeDocument/2006/relationships">
-  <p:cSld>
-    <p:spTree>
-      <p:nvGrpSpPr>
-        <p:cNvPr id="1" name=""/>
-        <p:cNvGrpSpPr/>
-        <p:nvPr/>
-      </p:nvGrpSpPr>
-      <p:grpSpPr/>
-      <p:sp>
-        <p:nvSpPr>
-          <p:cNvPr id="2" name="TextBox 1"/>
-          <p:cNvSpPr txBox="1"/>
-          <p:nvPr/>
-        </p:nvSpPr>
-        <p:spPr>
-          <a:xfrm>
-            <a:off x="914400" y="457200"/>
-            <a:ext cx="10058400" cy="1097280"/>
-          </a:xfrm>
-          <a:prstGeom prst="rect">
-            <a:avLst/>
-          </a:prstGeom>
-          <a:noFill/>
-        </p:spPr>
-        <p:txBody>
-          <a:bodyPr wrap="square">
-            <a:spAutoFit/>
-          </a:bodyPr>
-          <a:lstStyle/>
-          <a:p>
-            <a:pPr>
-              <a:defRPr sz="4000" b="1">
-                <a:solidFill>
-                  <a:srgbClr val="333333"/>
-                </a:solidFill>
-              </a:defRPr>
-            </a:pPr>
-            <a:r>
-              <a:t>Food101 데이터셋 (dataset.py)</a:t>
-            </a:r>
-          </a:p>
-        </p:txBody>
-      </p:sp>
-      <p:sp>
-        <p:nvSpPr>
-          <p:cNvPr id="3" name="TextBox 2"/>
-          <p:cNvSpPr txBox="1"/>
-          <p:nvPr/>
-        </p:nvSpPr>
-        <p:spPr>
-          <a:xfrm>
-            <a:off x="1371600" y="1828800"/>
-            <a:ext cx="9144000" cy="4114800"/>
-          </a:xfrm>
-          <a:prstGeom prst="rect">
-            <a:avLst/>
-          </a:prstGeom>
-          <a:noFill/>
-        </p:spPr>
-        <p:txBody>
-          <a:bodyPr wrap="square">
-            <a:spAutoFit/>
-          </a:bodyPr>
-          <a:lstStyle/>
-          <a:p/>
-          <a:p>
-            <a:pPr>
-              <a:defRPr sz="1800" b="0">
-                <a:solidFill>
-                  <a:srgbClr val="555555"/>
-                </a:solidFill>
-              </a:defRPr>
-            </a:pPr>
-            <a:r>
-              <a:t>from datasets import load_dataset</a:t>
-            </a:r>
-          </a:p>
-          <a:p>
-            <a:pPr>
-              <a:defRPr sz="1800" b="0">
-                <a:solidFill>
-                  <a:srgbClr val="555555"/>
-                </a:solidFill>
-              </a:defRPr>
-            </a:pPr>
-            <a:r>
-              <a:t>ds = load_dataset("ethz/food101", split="train")</a:t>
-            </a:r>
-          </a:p>
-          <a:p>
-            <a:pPr>
-              <a:defRPr sz="800" b="0">
-                <a:solidFill>
-                  <a:srgbClr val="333333"/>
-                </a:solidFill>
-              </a:defRPr>
-            </a:pPr>
-          </a:p>
-          <a:p>
-            <a:pPr>
-              <a:defRPr sz="2000" b="0">
-                <a:solidFill>
-                  <a:srgbClr val="333333"/>
-                </a:solidFill>
-              </a:defRPr>
-            </a:pPr>
-            <a:r>
-              <a:t>전체  75,750장</a:t>
-            </a:r>
-          </a:p>
-          <a:p>
-            <a:pPr>
-              <a:defRPr sz="2000" b="0">
-                <a:solidFill>
-                  <a:srgbClr val="333333"/>
-                </a:solidFill>
-              </a:defRPr>
-            </a:pPr>
-            <a:r>
-              <a:t>클래스  101종 (apple_pie, sushi, bibimbap, beignets...)</a:t>
-            </a:r>
-          </a:p>
-          <a:p>
-            <a:pPr>
-              <a:defRPr sz="2000" b="0">
-                <a:solidFill>
-                  <a:srgbClr val="333333"/>
-                </a:solidFill>
-              </a:defRPr>
-            </a:pPr>
-            <a:r>
-              <a:t>이미지 크기  평균 502 x 476 px</a:t>
-            </a:r>
-          </a:p>
-          <a:p>
-            <a:pPr>
-              <a:defRPr sz="800" b="0">
-                <a:solidFill>
-                  <a:srgbClr val="333333"/>
-                </a:solidFill>
-              </a:defRPr>
-            </a:pPr>
-          </a:p>
-          <a:p>
-            <a:pPr>
-              <a:defRPr sz="1800" b="0">
-                <a:solidFill>
-                  <a:srgbClr val="555555"/>
-                </a:solidFill>
-              </a:defRPr>
-            </a:pPr>
-            <a:r>
-              <a:t>100개 샘플 -&gt; pandas DataFrame -&gt; df.head(), df.describe()</a:t>
-            </a:r>
-          </a:p>
-          <a:p>
-            <a:pPr>
-              <a:defRPr sz="1800" b="0">
-                <a:solidFill>
-                  <a:srgbClr val="555555"/>
-                </a:solidFill>
-              </a:defRPr>
-            </a:pPr>
-            <a:r>
-              <a:t>실무에서 EDA(탐색적 데이터 분석)의 표준 방식.</a:t>
-            </a:r>
-          </a:p>
-        </p:txBody>
-      </p:sp>
-    </p:spTree>
-  </p:cSld>
-  <p:clrMapOvr>
-    <a:masterClrMapping/>
-  </p:clrMapOvr>
-</p:sld>
-</file>
-
-<file path=ppt/slides/slide11.xml><?xml version="1.0" encoding="utf-8"?>
-<p:sld xmlns:a="http://schemas.openxmlformats.org/drawingml/2006/main" xmlns:p="http://schemas.openxmlformats.org/presentationml/2006/main" xmlns:r="http://schemas.openxmlformats.org/officeDocument/2006/relationships">
-  <p:cSld>
-    <p:bg>
-      <p:bgPr>
-        <a:solidFill>
-          <a:srgbClr val="34495E"/>
-        </a:solidFill>
-        <a:effectLst/>
-      </p:bgPr>
-    </p:bg>
-    <p:spTree>
-      <p:nvGrpSpPr>
-        <p:cNvPr id="1" name=""/>
-        <p:cNvGrpSpPr/>
-        <p:nvPr/>
-      </p:nvGrpSpPr>
-      <p:grpSpPr/>
-      <p:sp>
-        <p:nvSpPr>
-          <p:cNvPr id="2" name="TextBox 1"/>
-          <p:cNvSpPr txBox="1"/>
-          <p:nvPr/>
-        </p:nvSpPr>
-        <p:spPr>
-          <a:xfrm>
-            <a:off x="914400" y="1828800"/>
-            <a:ext cx="10058400" cy="2743200"/>
-          </a:xfrm>
-          <a:prstGeom prst="rect">
-            <a:avLst/>
-          </a:prstGeom>
-          <a:noFill/>
-        </p:spPr>
-        <p:txBody>
-          <a:bodyPr wrap="square">
-            <a:spAutoFit/>
-          </a:bodyPr>
-          <a:lstStyle/>
-          <a:p/>
-          <a:p>
-            <a:pPr>
-              <a:defRPr sz="3800" b="1">
-                <a:solidFill>
-                  <a:srgbClr val="FFFFFF"/>
-                </a:solidFill>
-              </a:defRPr>
-            </a:pPr>
-            <a:r>
-              <a:t>Part 4. 이미지 전처리 파이프라인</a:t>
-            </a:r>
-          </a:p>
-          <a:p>
-            <a:pPr>
-              <a:defRPr sz="2200" b="0">
-                <a:solidFill>
-                  <a:srgbClr val="BBBBBB"/>
-                </a:solidFill>
-              </a:defRPr>
-            </a:pPr>
-            <a:r>
-              <a:t>Resize -&gt; Grayscale -&gt; Blur</a:t>
-            </a:r>
-          </a:p>
-          <a:p>
-            <a:pPr>
-              <a:defRPr sz="2200" b="0">
-                <a:solidFill>
-                  <a:srgbClr val="BBBBBB"/>
-                </a:solidFill>
-              </a:defRPr>
-            </a:pPr>
-            <a:r>
-              <a:t>Augmentation -&gt; Outlier Detection</a:t>
-            </a:r>
-          </a:p>
-        </p:txBody>
-      </p:sp>
-    </p:spTree>
-  </p:cSld>
-  <p:clrMapOvr>
-    <a:masterClrMapping/>
-  </p:clrMapOvr>
-</p:sld>
-</file>
-
-<file path=ppt/slides/slide12.xml><?xml version="1.0" encoding="utf-8"?>
-<p:sld xmlns:a="http://schemas.openxmlformats.org/drawingml/2006/main" xmlns:p="http://schemas.openxmlformats.org/presentationml/2006/main" xmlns:r="http://schemas.openxmlformats.org/officeDocument/2006/relationships">
-  <p:cSld>
-    <p:spTree>
-      <p:nvGrpSpPr>
-        <p:cNvPr id="1" name=""/>
-        <p:cNvGrpSpPr/>
-        <p:nvPr/>
-      </p:nvGrpSpPr>
-      <p:grpSpPr/>
-      <p:sp>
-        <p:nvSpPr>
-          <p:cNvPr id="2" name="TextBox 1"/>
-          <p:cNvSpPr txBox="1"/>
-          <p:nvPr/>
-        </p:nvSpPr>
-        <p:spPr>
-          <a:xfrm>
-            <a:off x="914400" y="457200"/>
-            <a:ext cx="10058400" cy="1097280"/>
-          </a:xfrm>
-          <a:prstGeom prst="rect">
-            <a:avLst/>
-          </a:prstGeom>
-          <a:noFill/>
-        </p:spPr>
-        <p:txBody>
-          <a:bodyPr wrap="square">
-            <a:spAutoFit/>
-          </a:bodyPr>
-          <a:lstStyle/>
-          <a:p>
-            <a:pPr>
-              <a:defRPr sz="4000" b="1">
-                <a:solidFill>
-                  <a:srgbClr val="333333"/>
-                </a:solidFill>
-              </a:defRPr>
-            </a:pPr>
-            <a:r>
-              <a:t>전처리 파이프라인</a:t>
-            </a:r>
-          </a:p>
-        </p:txBody>
-      </p:sp>
-      <p:sp>
-        <p:nvSpPr>
-          <p:cNvPr id="3" name="TextBox 2"/>
-          <p:cNvSpPr txBox="1"/>
-          <p:nvPr/>
-        </p:nvSpPr>
-        <p:spPr>
-          <a:xfrm>
-            <a:off x="1371600" y="1828800"/>
-            <a:ext cx="9144000" cy="4114800"/>
-          </a:xfrm>
-          <a:prstGeom prst="rect">
-            <a:avLst/>
-          </a:prstGeom>
-          <a:noFill/>
-        </p:spPr>
-        <p:txBody>
-          <a:bodyPr wrap="square">
-            <a:spAutoFit/>
-          </a:bodyPr>
-          <a:lstStyle/>
-          <a:p/>
-          <a:p>
-            <a:pPr>
-              <a:defRPr sz="2000" b="0">
-                <a:solidFill>
-                  <a:srgbClr val="333333"/>
-                </a:solidFill>
-              </a:defRPr>
-            </a:pPr>
-            <a:r>
-              <a:t>1. resize_224()           -&gt; 224 x 224</a:t>
-            </a:r>
-          </a:p>
-          <a:p>
-            <a:pPr>
-              <a:defRPr sz="2000" b="0">
-                <a:solidFill>
-                  <a:srgbClr val="333333"/>
-                </a:solidFill>
-              </a:defRPr>
-            </a:pPr>
-            <a:r>
-              <a:t>2. Grayscale 변환        -&gt; 1채널</a:t>
-            </a:r>
-          </a:p>
-          <a:p>
-            <a:pPr>
-              <a:defRPr sz="2000" b="0">
-                <a:solidFill>
-                  <a:srgbClr val="333333"/>
-                </a:solidFill>
-              </a:defRPr>
-            </a:pPr>
-            <a:r>
-              <a:t>3. [0, 1] Normalize      -&gt; 정규화</a:t>
-            </a:r>
-          </a:p>
-          <a:p>
-            <a:pPr>
-              <a:defRPr sz="2000" b="0">
-                <a:solidFill>
-                  <a:srgbClr val="333333"/>
-                </a:solidFill>
-              </a:defRPr>
-            </a:pPr>
-            <a:r>
-              <a:t>4. GaussianBlur(5x5)     -&gt; 노이즈 제거</a:t>
-            </a:r>
-          </a:p>
-          <a:p>
-            <a:pPr>
-              <a:defRPr sz="800" b="0">
-                <a:solidFill>
-                  <a:srgbClr val="333333"/>
-                </a:solidFill>
-              </a:defRPr>
-            </a:pPr>
-          </a:p>
-          <a:p>
-            <a:pPr>
-              <a:defRPr sz="2000" b="1">
-                <a:solidFill>
-                  <a:srgbClr val="E74C3C"/>
-                </a:solidFill>
-              </a:defRPr>
-            </a:pPr>
-            <a:r>
-              <a:t>5. 데이터 증강 (각각 저장)</a:t>
-            </a:r>
-          </a:p>
-          <a:p>
-            <a:pPr>
-              <a:defRPr sz="1800" b="0">
-                <a:solidFill>
-                  <a:srgbClr val="555555"/>
-                </a:solidFill>
-              </a:defRPr>
-            </a:pPr>
-            <a:r>
-              <a:t>   - horizontal_flip       좌우 반전</a:t>
-            </a:r>
-          </a:p>
-          <a:p>
-            <a:pPr>
-              <a:defRPr sz="1800" b="0">
-                <a:solidFill>
-                  <a:srgbClr val="555555"/>
-                </a:solidFill>
-              </a:defRPr>
-            </a:pPr>
-            <a:r>
-              <a:t>   - rotate_15             15도 회전</a:t>
-            </a:r>
-          </a:p>
-          <a:p>
-            <a:pPr>
-              <a:defRPr sz="1800" b="0">
-                <a:solidFill>
-                  <a:srgbClr val="555555"/>
-                </a:solidFill>
-              </a:defRPr>
-            </a:pPr>
-            <a:r>
-              <a:t>   - brightness +/-30       밝기 변화</a:t>
-            </a:r>
-          </a:p>
-          <a:p>
-            <a:pPr>
-              <a:defRPr sz="800" b="0">
-                <a:solidFill>
-                  <a:srgbClr val="333333"/>
-                </a:solidFill>
-              </a:defRPr>
-            </a:pPr>
-          </a:p>
-          <a:p>
-            <a:pPr>
-              <a:defRPr sz="2200" b="1">
-                <a:solidFill>
-                  <a:srgbClr val="27AE60"/>
-                </a:solidFill>
-              </a:defRPr>
-            </a:pPr>
-            <a:r>
-              <a:t>의존성: OpenCV + NumPy 만 사용</a:t>
-            </a:r>
-          </a:p>
-        </p:txBody>
-      </p:sp>
-    </p:spTree>
-  </p:cSld>
-  <p:clrMapOvr>
-    <a:masterClrMapping/>
-  </p:clrMapOvr>
-</p:sld>
-</file>
-
-<file path=ppt/slides/slide13.xml><?xml version="1.0" encoding="utf-8"?>
-<p:sld xmlns:a="http://schemas.openxmlformats.org/drawingml/2006/main" xmlns:p="http://schemas.openxmlformats.org/presentationml/2006/main" xmlns:r="http://schemas.openxmlformats.org/officeDocument/2006/relationships">
-  <p:cSld>
-    <p:spTree>
-      <p:nvGrpSpPr>
-        <p:cNvPr id="1" name=""/>
-        <p:cNvGrpSpPr/>
-        <p:nvPr/>
-      </p:nvGrpSpPr>
-      <p:grpSpPr/>
-      <p:sp>
-        <p:nvSpPr>
-          <p:cNvPr id="2" name="TextBox 1"/>
-          <p:cNvSpPr txBox="1"/>
-          <p:nvPr/>
-        </p:nvSpPr>
-        <p:spPr>
-          <a:xfrm>
-            <a:off x="914400" y="457200"/>
-            <a:ext cx="10058400" cy="1097280"/>
-          </a:xfrm>
-          <a:prstGeom prst="rect">
-            <a:avLst/>
-          </a:prstGeom>
-          <a:noFill/>
-        </p:spPr>
-        <p:txBody>
-          <a:bodyPr wrap="square">
-            <a:spAutoFit/>
-          </a:bodyPr>
-          <a:lstStyle/>
-          <a:p>
-            <a:pPr>
-              <a:defRPr sz="4000" b="1">
-                <a:solidFill>
-                  <a:srgbClr val="333333"/>
-                </a:solidFill>
-              </a:defRPr>
-            </a:pPr>
-            <a:r>
-              <a:t>이상치 탐지 (Outlier Detection)</a:t>
-            </a:r>
-          </a:p>
-        </p:txBody>
-      </p:sp>
-      <p:sp>
-        <p:nvSpPr>
-          <p:cNvPr id="3" name="TextBox 2"/>
-          <p:cNvSpPr txBox="1"/>
-          <p:nvPr/>
-        </p:nvSpPr>
-        <p:spPr>
-          <a:xfrm>
-            <a:off x="1371600" y="1828800"/>
-            <a:ext cx="4572000" cy="3657600"/>
-          </a:xfrm>
-          <a:prstGeom prst="rect">
-            <a:avLst/>
-          </a:prstGeom>
-          <a:noFill/>
-        </p:spPr>
-        <p:txBody>
-          <a:bodyPr wrap="square">
-            <a:spAutoFit/>
-          </a:bodyPr>
-          <a:lstStyle/>
-          <a:p/>
-          <a:p>
-            <a:pPr>
-              <a:defRPr sz="2000" b="1">
-                <a:solidFill>
-                  <a:srgbClr val="E74C3C"/>
-                </a:solidFill>
-              </a:defRPr>
-            </a:pPr>
-            <a:r>
-              <a:t>1) 너무 어두운 이미지</a:t>
-            </a:r>
-          </a:p>
-          <a:p>
-            <a:pPr>
-              <a:defRPr sz="1600" b="0">
-                <a:solidFill>
-                  <a:srgbClr val="555555"/>
-                </a:solidFill>
-              </a:defRPr>
-            </a:pPr>
-            <a:r>
-              <a:t>cv2.cvtColor -&gt; GRAY</a:t>
-            </a:r>
-          </a:p>
-          <a:p>
-            <a:pPr>
-              <a:defRPr sz="1600" b="0">
-                <a:solidFill>
-                  <a:srgbClr val="555555"/>
-                </a:solidFill>
-              </a:defRPr>
-            </a:pPr>
-            <a:r>
-              <a:t>np.mean(gray) &lt; 30 -&gt; skip</a:t>
-            </a:r>
-          </a:p>
-          <a:p>
-            <a:pPr>
-              <a:defRPr sz="1000" b="0">
-                <a:solidFill>
-                  <a:srgbClr val="333333"/>
-                </a:solidFill>
-              </a:defRPr>
-            </a:pPr>
-          </a:p>
-          <a:p>
-            <a:pPr>
-              <a:defRPr sz="2000" b="1">
-                <a:solidFill>
-                  <a:srgbClr val="E74C3C"/>
-                </a:solidFill>
-              </a:defRPr>
-            </a:pPr>
-            <a:r>
-              <a:t>2) 객체 너무 작은 이미지</a:t>
-            </a:r>
-          </a:p>
-          <a:p>
-            <a:pPr>
-              <a:defRPr sz="1600" b="0">
-                <a:solidFill>
-                  <a:srgbClr val="555555"/>
-                </a:solidFill>
-              </a:defRPr>
-            </a:pPr>
-            <a:r>
-              <a:t>cv2.threshold(OTSU) -&gt; binary</a:t>
-            </a:r>
-          </a:p>
-          <a:p>
-            <a:pPr>
-              <a:defRPr sz="1600" b="0">
-                <a:solidFill>
-                  <a:srgbClr val="555555"/>
-                </a:solidFill>
-              </a:defRPr>
-            </a:pPr>
-            <a:r>
-              <a:t>cv2.findContours -&gt; max_area</a:t>
-            </a:r>
-          </a:p>
-          <a:p>
-            <a:pPr>
-              <a:defRPr sz="1600" b="0">
-                <a:solidFill>
-                  <a:srgbClr val="555555"/>
-                </a:solidFill>
-              </a:defRPr>
-            </a:pPr>
-            <a:r>
-              <a:t>max_area / (h*w) &lt; 0.1 -&gt; skip</a:t>
-            </a:r>
-          </a:p>
-        </p:txBody>
-      </p:sp>
-    </p:spTree>
-  </p:cSld>
-  <p:clrMapOvr>
-    <a:masterClrMapping/>
-  </p:clrMapOvr>
-</p:sld>
-</file>
-
-<file path=ppt/slides/slide14.xml><?xml version="1.0" encoding="utf-8"?>
-<p:sld xmlns:a="http://schemas.openxmlformats.org/drawingml/2006/main" xmlns:p="http://schemas.openxmlformats.org/presentationml/2006/main" xmlns:r="http://schemas.openxmlformats.org/officeDocument/2006/relationships">
-  <p:cSld>
-    <p:spTree>
-      <p:nvGrpSpPr>
-        <p:cNvPr id="1" name=""/>
-        <p:cNvGrpSpPr/>
-        <p:nvPr/>
-      </p:nvGrpSpPr>
-      <p:grpSpPr/>
-      <p:sp>
-        <p:nvSpPr>
-          <p:cNvPr id="2" name="TextBox 1"/>
-          <p:cNvSpPr txBox="1"/>
-          <p:nvPr/>
-        </p:nvSpPr>
-        <p:spPr>
-          <a:xfrm>
-            <a:off x="914400" y="457200"/>
-            <a:ext cx="10058400" cy="1097280"/>
-          </a:xfrm>
-          <a:prstGeom prst="rect">
-            <a:avLst/>
-          </a:prstGeom>
-          <a:noFill/>
-        </p:spPr>
-        <p:txBody>
-          <a:bodyPr wrap="square">
-            <a:spAutoFit/>
-          </a:bodyPr>
-          <a:lstStyle/>
-          <a:p>
-            <a:pPr>
-              <a:defRPr sz="4000" b="1">
-                <a:solidFill>
-                  <a:srgbClr val="333333"/>
-                </a:solidFill>
-              </a:defRPr>
-            </a:pPr>
-            <a:r>
-              <a:t>전처리 샘플</a:t>
-            </a:r>
-          </a:p>
-        </p:txBody>
-      </p:sp>
-      <p:pic>
-        <p:nvPicPr>
-          <p:cNvPr id="3" name="Picture 2" descr="01_beignets_raw.jpg"/>
-          <p:cNvPicPr>
-            <a:picLocks noChangeAspect="1"/>
-          </p:cNvPicPr>
-          <p:nvPr/>
-        </p:nvPicPr>
-        <p:blipFill>
-          <a:blip r:embed="rId2"/>
-          <a:stretch>
-            <a:fillRect/>
-          </a:stretch>
-        </p:blipFill>
-        <p:spPr>
-          <a:xfrm>
-            <a:off x="1828800" y="1645920"/>
-            <a:ext cx="1828800" cy="2438400"/>
-          </a:xfrm>
-          <a:prstGeom prst="rect">
-            <a:avLst/>
-          </a:prstGeom>
-        </p:spPr>
-      </p:pic>
-      <p:pic>
-        <p:nvPicPr>
-          <p:cNvPr id="4" name="Picture 3" descr="01_beignets_preprocessed.jpg"/>
-          <p:cNvPicPr>
-            <a:picLocks noChangeAspect="1"/>
-          </p:cNvPicPr>
-          <p:nvPr/>
-        </p:nvPicPr>
-        <p:blipFill>
-          <a:blip r:embed="rId3"/>
-          <a:stretch>
-            <a:fillRect/>
-          </a:stretch>
-        </p:blipFill>
-        <p:spPr>
-          <a:xfrm>
-            <a:off x="1828800" y="3931920"/>
-            <a:ext cx="1828800" cy="1828800"/>
-          </a:xfrm>
-          <a:prstGeom prst="rect">
-            <a:avLst/>
-          </a:prstGeom>
-        </p:spPr>
-      </p:pic>
-      <p:sp>
-        <p:nvSpPr>
-          <p:cNvPr id="5" name="TextBox 4"/>
-          <p:cNvSpPr txBox="1"/>
-          <p:nvPr/>
-        </p:nvSpPr>
-        <p:spPr>
-          <a:xfrm>
-            <a:off x="1828800" y="1188720"/>
-            <a:ext cx="1828800" cy="365760"/>
-          </a:xfrm>
-          <a:prstGeom prst="rect">
-            <a:avLst/>
-          </a:prstGeom>
-          <a:noFill/>
-        </p:spPr>
-        <p:txBody>
-          <a:bodyPr wrap="square">
-            <a:spAutoFit/>
-          </a:bodyPr>
-          <a:lstStyle/>
-          <a:p/>
-          <a:p>
-            <a:pPr algn="ctr">
-              <a:defRPr sz="1400" b="0">
-                <a:solidFill>
-                  <a:srgbClr val="555555"/>
-                </a:solidFill>
-              </a:defRPr>
-            </a:pPr>
-            <a:r>
-              <a:t>original #1</a:t>
-            </a:r>
-          </a:p>
-        </p:txBody>
-      </p:sp>
-      <p:sp>
-        <p:nvSpPr>
-          <p:cNvPr id="6" name="TextBox 5"/>
-          <p:cNvSpPr txBox="1"/>
-          <p:nvPr/>
-        </p:nvSpPr>
-        <p:spPr>
-          <a:xfrm>
-            <a:off x="1828800" y="3474720"/>
-            <a:ext cx="1828800" cy="365760"/>
-          </a:xfrm>
-          <a:prstGeom prst="rect">
-            <a:avLst/>
-          </a:prstGeom>
-          <a:noFill/>
-        </p:spPr>
-        <p:txBody>
-          <a:bodyPr wrap="square">
-            <a:spAutoFit/>
-          </a:bodyPr>
-          <a:lstStyle/>
-          <a:p/>
-          <a:p>
-            <a:pPr algn="ctr">
-              <a:defRPr sz="1400" b="0">
-                <a:solidFill>
-                  <a:srgbClr val="555555"/>
-                </a:solidFill>
-              </a:defRPr>
-            </a:pPr>
-            <a:r>
-              <a:t>processed #1</a:t>
-            </a:r>
-          </a:p>
-        </p:txBody>
-      </p:sp>
-      <p:pic>
-        <p:nvPicPr>
-          <p:cNvPr id="7" name="Picture 6" descr="02_beignets_raw.jpg"/>
-          <p:cNvPicPr>
-            <a:picLocks noChangeAspect="1"/>
-          </p:cNvPicPr>
-          <p:nvPr/>
-        </p:nvPicPr>
-        <p:blipFill>
-          <a:blip r:embed="rId4"/>
-          <a:stretch>
-            <a:fillRect/>
-          </a:stretch>
-        </p:blipFill>
-        <p:spPr>
-          <a:xfrm>
-            <a:off x="6400800" y="1645920"/>
-            <a:ext cx="1828800" cy="1828800"/>
-          </a:xfrm>
-          <a:prstGeom prst="rect">
-            <a:avLst/>
-          </a:prstGeom>
-        </p:spPr>
-      </p:pic>
-      <p:pic>
-        <p:nvPicPr>
-          <p:cNvPr id="8" name="Picture 7" descr="02_beignets_preprocessed.jpg"/>
-          <p:cNvPicPr>
-            <a:picLocks noChangeAspect="1"/>
-          </p:cNvPicPr>
-          <p:nvPr/>
-        </p:nvPicPr>
-        <p:blipFill>
-          <a:blip r:embed="rId5"/>
-          <a:stretch>
-            <a:fillRect/>
-          </a:stretch>
-        </p:blipFill>
-        <p:spPr>
-          <a:xfrm>
-            <a:off x="6400800" y="3931920"/>
-            <a:ext cx="1828800" cy="1828800"/>
-          </a:xfrm>
-          <a:prstGeom prst="rect">
-            <a:avLst/>
-          </a:prstGeom>
-        </p:spPr>
-      </p:pic>
-      <p:sp>
-        <p:nvSpPr>
-          <p:cNvPr id="9" name="TextBox 8"/>
-          <p:cNvSpPr txBox="1"/>
-          <p:nvPr/>
-        </p:nvSpPr>
-        <p:spPr>
-          <a:xfrm>
-            <a:off x="6400800" y="1188720"/>
-            <a:ext cx="1828800" cy="365760"/>
-          </a:xfrm>
-          <a:prstGeom prst="rect">
-            <a:avLst/>
-          </a:prstGeom>
-          <a:noFill/>
-        </p:spPr>
-        <p:txBody>
-          <a:bodyPr wrap="square">
-            <a:spAutoFit/>
-          </a:bodyPr>
-          <a:lstStyle/>
-          <a:p/>
-          <a:p>
-            <a:pPr algn="ctr">
-              <a:defRPr sz="1400" b="0">
-                <a:solidFill>
-                  <a:srgbClr val="555555"/>
-                </a:solidFill>
-              </a:defRPr>
-            </a:pPr>
-            <a:r>
-              <a:t>original #2</a:t>
-            </a:r>
-          </a:p>
-        </p:txBody>
-      </p:sp>
-      <p:sp>
-        <p:nvSpPr>
-          <p:cNvPr id="10" name="TextBox 9"/>
-          <p:cNvSpPr txBox="1"/>
-          <p:nvPr/>
-        </p:nvSpPr>
-        <p:spPr>
-          <a:xfrm>
-            <a:off x="6400800" y="3474720"/>
-            <a:ext cx="1828800" cy="365760"/>
-          </a:xfrm>
-          <a:prstGeom prst="rect">
-            <a:avLst/>
-          </a:prstGeom>
-          <a:noFill/>
-        </p:spPr>
-        <p:txBody>
-          <a:bodyPr wrap="square">
-            <a:spAutoFit/>
-          </a:bodyPr>
-          <a:lstStyle/>
-          <a:p/>
-          <a:p>
-            <a:pPr algn="ctr">
-              <a:defRPr sz="1400" b="0">
-                <a:solidFill>
-                  <a:srgbClr val="555555"/>
-                </a:solidFill>
-              </a:defRPr>
-            </a:pPr>
-            <a:r>
-              <a:t>processed #2</a:t>
-            </a:r>
-          </a:p>
-        </p:txBody>
-      </p:sp>
-      <p:sp>
-        <p:nvSpPr>
-          <p:cNvPr id="11" name="TextBox 10"/>
-          <p:cNvSpPr txBox="1"/>
-          <p:nvPr/>
-        </p:nvSpPr>
-        <p:spPr>
-          <a:xfrm>
-            <a:off x="1371600" y="5760720"/>
-            <a:ext cx="9144000" cy="457200"/>
-          </a:xfrm>
-          <a:prstGeom prst="rect">
-            <a:avLst/>
-          </a:prstGeom>
-          <a:noFill/>
-        </p:spPr>
-        <p:txBody>
-          <a:bodyPr wrap="square">
-            <a:spAutoFit/>
-          </a:bodyPr>
-          <a:lstStyle/>
-          <a:p/>
-          <a:p>
-            <a:pPr>
-              <a:defRPr sz="1800" b="0">
-                <a:solidFill>
-                  <a:srgbClr val="555555"/>
-                </a:solidFill>
-              </a:defRPr>
-            </a:pPr>
-            <a:r>
-              <a:t>5 samples x 4 types (original/flip/rotate/bright) = 20 images</a:t>
-            </a:r>
-          </a:p>
-        </p:txBody>
-      </p:sp>
-    </p:spTree>
-  </p:cSld>
-  <p:clrMapOvr>
-    <a:masterClrMapping/>
-  </p:clrMapOvr>
-</p:sld>
-</file>
-
-<file path=ppt/slides/slide15.xml><?xml version="1.0" encoding="utf-8"?>
-<p:sld xmlns:a="http://schemas.openxmlformats.org/drawingml/2006/main" xmlns:p="http://schemas.openxmlformats.org/presentationml/2006/main" xmlns:r="http://schemas.openxmlformats.org/officeDocument/2006/relationships">
-  <p:cSld>
-    <p:spTree>
-      <p:nvGrpSpPr>
-        <p:cNvPr id="1" name=""/>
-        <p:cNvGrpSpPr/>
-        <p:nvPr/>
-      </p:nvGrpSpPr>
-      <p:grpSpPr/>
-      <p:sp>
-        <p:nvSpPr>
-          <p:cNvPr id="2" name="TextBox 1"/>
-          <p:cNvSpPr txBox="1"/>
-          <p:nvPr/>
-        </p:nvSpPr>
-        <p:spPr>
-          <a:xfrm>
-            <a:off x="914400" y="457200"/>
-            <a:ext cx="10058400" cy="1097280"/>
-          </a:xfrm>
-          <a:prstGeom prst="rect">
-            <a:avLst/>
-          </a:prstGeom>
-          <a:noFill/>
-        </p:spPr>
-        <p:txBody>
-          <a:bodyPr wrap="square">
-            <a:spAutoFit/>
-          </a:bodyPr>
-          <a:lstStyle/>
-          <a:p>
-            <a:pPr>
-              <a:defRPr sz="4000" b="1">
-                <a:solidFill>
-                  <a:srgbClr val="333333"/>
-                </a:solidFill>
-              </a:defRPr>
-            </a:pPr>
-            <a:r>
-              <a:t>제출 항목 체크리스트</a:t>
-            </a:r>
-          </a:p>
-        </p:txBody>
-      </p:sp>
-      <p:sp>
-        <p:nvSpPr>
-          <p:cNvPr id="3" name="TextBox 2"/>
-          <p:cNvSpPr txBox="1"/>
-          <p:nvPr/>
-        </p:nvSpPr>
-        <p:spPr>
-          <a:xfrm>
-            <a:off x="1371600" y="1828800"/>
-            <a:ext cx="9144000" cy="4114800"/>
-          </a:xfrm>
-          <a:prstGeom prst="rect">
-            <a:avLst/>
-          </a:prstGeom>
-          <a:noFill/>
-        </p:spPr>
-        <p:txBody>
-          <a:bodyPr wrap="square">
-            <a:spAutoFit/>
-          </a:bodyPr>
-          <a:lstStyle/>
-          <a:p/>
-          <a:p>
-            <a:pPr>
-              <a:defRPr sz="1800" b="0">
-                <a:solidFill>
-                  <a:srgbClr val="27AE60"/>
-                </a:solidFill>
-              </a:defRPr>
-            </a:pPr>
-            <a:r>
-              <a:t>  [O] Git 저장소 구성</a:t>
-            </a:r>
-          </a:p>
-          <a:p>
-            <a:pPr>
-              <a:defRPr sz="1800" b="0">
-                <a:solidFill>
-                  <a:srgbClr val="27AE60"/>
-                </a:solidFill>
-              </a:defRPr>
-            </a:pPr>
-            <a:r>
-              <a:t>  [O] Branch / PR / Merge</a:t>
-            </a:r>
-          </a:p>
-          <a:p>
-            <a:pPr>
-              <a:defRPr sz="1800" b="0">
-                <a:solidFill>
-                  <a:srgbClr val="27AE60"/>
-                </a:solidFill>
-              </a:defRPr>
-            </a:pPr>
-            <a:r>
-              <a:t>  [O] red.py 빨간색 검출</a:t>
-            </a:r>
-          </a:p>
-          <a:p>
-            <a:pPr>
-              <a:defRPr sz="1800" b="0">
-                <a:solidFill>
-                  <a:srgbClr val="27AE60"/>
-                </a:solidFill>
-              </a:defRPr>
-            </a:pPr>
-            <a:r>
-              <a:t>  [O] dataset.py Food101 로드 + pandas</a:t>
-            </a:r>
-          </a:p>
-          <a:p>
-            <a:pPr>
-              <a:defRPr sz="1800" b="0">
-                <a:solidFill>
-                  <a:srgbClr val="27AE60"/>
-                </a:solidFill>
-              </a:defRPr>
-            </a:pPr>
-            <a:r>
-              <a:t>  [O] image_preprocessing.py 전처리 파이프라인</a:t>
-            </a:r>
-          </a:p>
-          <a:p>
-            <a:pPr>
-              <a:defRPr sz="1800" b="0">
-                <a:solidFill>
-                  <a:srgbClr val="27AE60"/>
-                </a:solidFill>
-              </a:defRPr>
-            </a:pPr>
-            <a:r>
-              <a:t>  [O] Resize 224x224</a:t>
-            </a:r>
-          </a:p>
-          <a:p>
-            <a:pPr>
-              <a:defRPr sz="1800" b="0">
-                <a:solidFill>
-                  <a:srgbClr val="27AE60"/>
-                </a:solidFill>
-              </a:defRPr>
-            </a:pPr>
-            <a:r>
-              <a:t>  [O] Grayscale + Normalize</a:t>
-            </a:r>
-          </a:p>
-          <a:p>
-            <a:pPr>
-              <a:defRPr sz="1800" b="0">
-                <a:solidFill>
-                  <a:srgbClr val="27AE60"/>
-                </a:solidFill>
-              </a:defRPr>
-            </a:pPr>
-            <a:r>
-              <a:t>  [O] GaussianBlur 노이즈 제거</a:t>
-            </a:r>
-          </a:p>
-          <a:p>
-            <a:pPr>
-              <a:defRPr sz="1800" b="0">
-                <a:solidFill>
-                  <a:srgbClr val="27AE60"/>
-                </a:solidFill>
-              </a:defRPr>
-            </a:pPr>
-            <a:r>
-              <a:t>  [O] 데이터 증강 3종 (flip, rotate, bright)</a:t>
-            </a:r>
-          </a:p>
-          <a:p>
-            <a:pPr>
-              <a:defRPr sz="1800" b="0">
-                <a:solidFill>
-                  <a:srgbClr val="27AE60"/>
-                </a:solidFill>
-              </a:defRPr>
-            </a:pPr>
-            <a:r>
-              <a:t>  [O] 이상치 탐지 2종 (dark, small object)</a:t>
-            </a:r>
-          </a:p>
-          <a:p>
-            <a:pPr>
-              <a:defRPr sz="1800" b="0">
-                <a:solidFill>
-                  <a:srgbClr val="27AE60"/>
-                </a:solidFill>
-              </a:defRPr>
-            </a:pPr>
-            <a:r>
-              <a:t>  [O] 전처리 결과물 20장</a:t>
-            </a:r>
-          </a:p>
-          <a:p>
-            <a:pPr>
-              <a:defRPr sz="1800" b="0">
-                <a:solidFill>
-                  <a:srgbClr val="27AE60"/>
-                </a:solidFill>
-              </a:defRPr>
-            </a:pPr>
-            <a:r>
-              <a:t>  [O] PPT 보고서 (본 문서)</a:t>
-            </a:r>
-          </a:p>
-        </p:txBody>
-      </p:sp>
-    </p:spTree>
-  </p:cSld>
-  <p:clrMapOvr>
-    <a:masterClrMapping/>
-  </p:clrMapOvr>
-</p:sld>
-</file>
-
-<file path=ppt/slides/slide16.xml><?xml version="1.0" encoding="utf-8"?>
-<p:sld xmlns:a="http://schemas.openxmlformats.org/drawingml/2006/main" xmlns:p="http://schemas.openxmlformats.org/presentationml/2006/main" xmlns:r="http://schemas.openxmlformats.org/officeDocument/2006/relationships">
-  <p:cSld>
-    <p:bg>
-      <p:bgPr>
-        <a:solidFill>
-          <a:srgbClr val="2C3E50"/>
-        </a:solidFill>
-        <a:effectLst/>
-      </p:bgPr>
-    </p:bg>
-    <p:spTree>
-      <p:nvGrpSpPr>
-        <p:cNvPr id="1" name=""/>
-        <p:cNvGrpSpPr/>
-        <p:nvPr/>
-      </p:nvGrpSpPr>
-      <p:grpSpPr/>
-      <p:sp>
-        <p:nvSpPr>
-          <p:cNvPr id="2" name="TextBox 1"/>
-          <p:cNvSpPr txBox="1"/>
-          <p:nvPr/>
-        </p:nvSpPr>
-        <p:spPr>
-          <a:xfrm>
-            <a:off x="1371600" y="914400"/>
-            <a:ext cx="9144000" cy="5029200"/>
-          </a:xfrm>
-          <a:prstGeom prst="rect">
-            <a:avLst/>
-          </a:prstGeom>
-          <a:noFill/>
-        </p:spPr>
-        <p:txBody>
-          <a:bodyPr wrap="square">
-            <a:spAutoFit/>
-          </a:bodyPr>
-          <a:lstStyle/>
-          <a:p/>
-          <a:p>
-            <a:pPr>
-              <a:defRPr sz="3600" b="1">
-                <a:solidFill>
-                  <a:srgbClr val="FFFFFF"/>
-                </a:solidFill>
-              </a:defRPr>
-            </a:pPr>
-            <a:r>
-              <a:t>배운 점</a:t>
-            </a:r>
-          </a:p>
-          <a:p>
-            <a:pPr>
-              <a:defRPr sz="1000" b="0">
-                <a:solidFill>
-                  <a:srgbClr val="333333"/>
-                </a:solidFill>
-              </a:defRPr>
-            </a:pPr>
-          </a:p>
-          <a:p>
-            <a:pPr>
-              <a:defRPr sz="1800" b="1">
-                <a:solidFill>
-                  <a:srgbClr val="FFFFFF"/>
-                </a:solidFill>
-              </a:defRPr>
-            </a:pPr>
-            <a:r>
-              <a:t>1. HSV가 RGB보다 실용적이다</a:t>
-            </a:r>
-          </a:p>
-          <a:p>
-            <a:pPr>
-              <a:defRPr sz="1600" b="0">
-                <a:solidFill>
-                  <a:srgbClr val="AAAAAA"/>
-                </a:solidFill>
-              </a:defRPr>
-            </a:pPr>
-            <a:r>
-              <a:t>   조명 변화에 강하고, 인간이 인식하는 '색상'에 가깝다.</a:t>
-            </a:r>
-          </a:p>
-          <a:p>
-            <a:pPr>
-              <a:defRPr sz="800" b="0">
-                <a:solidFill>
-                  <a:srgbClr val="333333"/>
-                </a:solidFill>
-              </a:defRPr>
-            </a:pPr>
-          </a:p>
-          <a:p>
-            <a:pPr>
-              <a:defRPr sz="1800" b="1">
-                <a:solidFill>
-                  <a:srgbClr val="FFFFFF"/>
-                </a:solidFill>
-              </a:defRPr>
-            </a:pPr>
-            <a:r>
-              <a:t>2. cv2.bitwise_or vs + 연산자</a:t>
-            </a:r>
-          </a:p>
-          <a:p>
-            <a:pPr>
-              <a:defRPr sz="1600" b="0">
-                <a:solidFill>
-                  <a:srgbClr val="AAAAAA"/>
-                </a:solidFill>
-              </a:defRPr>
-            </a:pPr>
-            <a:r>
-              <a:t>   uint8에서 255+255=510 overflow. 비트 연산이 정확하다.</a:t>
-            </a:r>
-          </a:p>
-          <a:p>
-            <a:pPr>
-              <a:defRPr sz="800" b="0">
-                <a:solidFill>
-                  <a:srgbClr val="333333"/>
-                </a:solidFill>
-              </a:defRPr>
-            </a:pPr>
-          </a:p>
-          <a:p>
-            <a:pPr>
-              <a:defRPr sz="1800" b="1">
-                <a:solidFill>
-                  <a:srgbClr val="FFFFFF"/>
-                </a:solidFill>
-              </a:defRPr>
-            </a:pPr>
-            <a:r>
-              <a:t>3. pandas로 EDA 먼저, 전처리는 그 다음</a:t>
-            </a:r>
-          </a:p>
-          <a:p>
-            <a:pPr>
-              <a:defRPr sz="1600" b="0">
-                <a:solidFill>
-                  <a:srgbClr val="AAAAAA"/>
-                </a:solidFill>
-              </a:defRPr>
-            </a:pPr>
-            <a:r>
-              <a:t>   데이터 분포를 먼저 파악하고 전처리 전략을 세운다.</a:t>
-            </a:r>
-          </a:p>
-          <a:p>
-            <a:pPr>
-              <a:defRPr sz="800" b="0">
-                <a:solidFill>
-                  <a:srgbClr val="333333"/>
-                </a:solidFill>
-              </a:defRPr>
-            </a:pPr>
-          </a:p>
-          <a:p>
-            <a:pPr>
-              <a:defRPr sz="1800" b="1">
-                <a:solidFill>
-                  <a:srgbClr val="FFFFFF"/>
-                </a:solidFill>
-              </a:defRPr>
-            </a:pPr>
-            <a:r>
-              <a:t>4. Git 브랜치 전략은 혼자여도 의미 있다</a:t>
-            </a:r>
-          </a:p>
-          <a:p>
-            <a:pPr>
-              <a:defRPr sz="1600" b="0">
-                <a:solidFill>
-                  <a:srgbClr val="AAAAAA"/>
-                </a:solidFill>
-              </a:defRPr>
-            </a:pPr>
-            <a:r>
-              <a:t>   실수 복구가 쉽고, 작업 단위가 명확해진다.</a:t>
-            </a:r>
-          </a:p>
-          <a:p>
-            <a:pPr>
-              <a:defRPr sz="800" b="0">
-                <a:solidFill>
-                  <a:srgbClr val="333333"/>
-                </a:solidFill>
-              </a:defRPr>
-            </a:pPr>
-          </a:p>
-          <a:p>
-            <a:pPr>
-              <a:defRPr sz="1800" b="1">
-                <a:solidFill>
-                  <a:srgbClr val="FFFFFF"/>
-                </a:solidFill>
-              </a:defRPr>
-            </a:pPr>
-            <a:r>
-              <a:t>5. OpenCV + NumPy만으로 충분한 파이프라인</a:t>
-            </a:r>
-          </a:p>
-          <a:p>
-            <a:pPr>
-              <a:defRPr sz="1600" b="0">
-                <a:solidFill>
-                  <a:srgbClr val="AAAAAA"/>
-                </a:solidFill>
-              </a:defRPr>
-            </a:pPr>
-            <a:r>
-              <a:t>   추가 라이브러리 의존 없이 기본 함수 조합으로 구현했다.</a:t>
             </a:r>
           </a:p>
         </p:txBody>
@@ -4618,14 +3196,6 @@
 <file path=ppt/slides/slide2.xml><?xml version="1.0" encoding="utf-8"?>
 <p:sld xmlns:a="http://schemas.openxmlformats.org/drawingml/2006/main" xmlns:p="http://schemas.openxmlformats.org/presentationml/2006/main" xmlns:r="http://schemas.openxmlformats.org/officeDocument/2006/relationships">
   <p:cSld>
-    <p:bg>
-      <p:bgPr>
-        <a:solidFill>
-          <a:srgbClr val="34495E"/>
-        </a:solidFill>
-        <a:effectLst/>
-      </p:bgPr>
-    </p:bg>
     <p:spTree>
       <p:nvGrpSpPr>
         <p:cNvPr id="1" name=""/>
@@ -4635,14 +3205,57 @@
       <p:grpSpPr/>
       <p:sp>
         <p:nvSpPr>
-          <p:cNvPr id="2" name="TextBox 1"/>
+          <p:cNvPr id="2" name="Rectangle 1"/>
+          <p:cNvSpPr/>
+          <p:nvPr/>
+        </p:nvSpPr>
+        <p:spPr>
+          <a:xfrm>
+            <a:off x="0" y="0"/>
+            <a:ext cx="12191695" cy="1005840"/>
+          </a:xfrm>
+          <a:prstGeom prst="rect">
+            <a:avLst/>
+          </a:prstGeom>
+          <a:solidFill>
+            <a:srgbClr val="34495E"/>
+          </a:solidFill>
+          <a:ln>
+            <a:noFill/>
+          </a:ln>
+        </p:spPr>
+        <p:style>
+          <a:lnRef idx="1">
+            <a:schemeClr val="accent1"/>
+          </a:lnRef>
+          <a:fillRef idx="3">
+            <a:schemeClr val="accent1"/>
+          </a:fillRef>
+          <a:effectRef idx="2">
+            <a:schemeClr val="accent1"/>
+          </a:effectRef>
+          <a:fontRef idx="minor">
+            <a:schemeClr val="lt1"/>
+          </a:fontRef>
+        </p:style>
+        <p:txBody>
+          <a:bodyPr rtlCol="0" anchor="ctr"/>
+          <a:lstStyle/>
+          <a:p>
+            <a:pPr algn="ctr"/>
+          </a:p>
+        </p:txBody>
+      </p:sp>
+      <p:sp>
+        <p:nvSpPr>
+          <p:cNvPr id="3" name="TextBox 2"/>
           <p:cNvSpPr txBox="1"/>
           <p:nvPr/>
         </p:nvSpPr>
         <p:spPr>
           <a:xfrm>
-            <a:off x="914400" y="2286000"/>
-            <a:ext cx="10058400" cy="1828800"/>
+            <a:off x="914400" y="137160"/>
+            <a:ext cx="10058400" cy="731520"/>
           </a:xfrm>
           <a:prstGeom prst="rect">
             <a:avLst/>
@@ -4654,29 +3267,190 @@
             <a:spAutoFit/>
           </a:bodyPr>
           <a:lstStyle/>
+          <a:p>
+            <a:pPr>
+              <a:defRPr sz="3200" b="1">
+                <a:solidFill>
+                  <a:srgbClr val="FFFFFF"/>
+                </a:solidFill>
+              </a:defRPr>
+            </a:pPr>
+            <a:r>
+              <a:t>과제 개요</a:t>
+            </a:r>
+          </a:p>
+        </p:txBody>
+      </p:sp>
+      <p:sp>
+        <p:nvSpPr>
+          <p:cNvPr id="4" name="TextBox 3"/>
+          <p:cNvSpPr txBox="1"/>
+          <p:nvPr/>
+        </p:nvSpPr>
+        <p:spPr>
+          <a:xfrm>
+            <a:off x="1371600" y="1371600"/>
+            <a:ext cx="9144000" cy="4114800"/>
+          </a:xfrm>
+          <a:prstGeom prst="rect">
+            <a:avLst/>
+          </a:prstGeom>
+          <a:noFill/>
+        </p:spPr>
+        <p:txBody>
+          <a:bodyPr wrap="square">
+            <a:spAutoFit/>
+          </a:bodyPr>
+          <a:lstStyle/>
           <a:p/>
           <a:p>
             <a:pPr>
-              <a:defRPr sz="3800" b="1">
-                <a:solidFill>
-                  <a:srgbClr val="FFFFFF"/>
-                </a:solidFill>
-              </a:defRPr>
-            </a:pPr>
-            <a:r>
-              <a:t>Part 1. Git 브랜치 전략 &amp; 코드 관리</a:t>
-            </a:r>
-          </a:p>
-          <a:p>
-            <a:pPr>
-              <a:defRPr sz="2200" b="0">
-                <a:solidFill>
-                  <a:srgbClr val="BBBBBB"/>
-                </a:solidFill>
-              </a:defRPr>
-            </a:pPr>
-            <a:r>
-              <a:t>Git Flow · Branch · PR · Merge</a:t>
+              <a:defRPr sz="2200" b="1">
+                <a:solidFill>
+                  <a:srgbClr val="34495E"/>
+                </a:solidFill>
+              </a:defRPr>
+            </a:pPr>
+            <a:r>
+              <a:t>[배경]</a:t>
+            </a:r>
+          </a:p>
+          <a:p>
+            <a:pPr>
+              <a:defRPr sz="1800" b="0">
+                <a:solidFill>
+                  <a:srgbClr val="333333"/>
+                </a:solidFill>
+              </a:defRPr>
+            </a:pPr>
+            <a:r>
+              <a:t>AI 기반 신제품 조직 신설, Computer Vision 기술로 사용자 편의성 증대 목표.</a:t>
+            </a:r>
+          </a:p>
+          <a:p>
+            <a:pPr>
+              <a:defRPr sz="1800" b="0">
+                <a:solidFill>
+                  <a:srgbClr val="333333"/>
+                </a:solidFill>
+              </a:defRPr>
+            </a:pPr>
+            <a:r>
+              <a:t>효율적 코드 관리와 픽셀 단위 이미지 처리는 CV 프로젝트 기초 역량.</a:t>
+            </a:r>
+          </a:p>
+          <a:p>
+            <a:pPr>
+              <a:defRPr sz="800" b="0">
+                <a:solidFill>
+                  <a:srgbClr val="333333"/>
+                </a:solidFill>
+              </a:defRPr>
+            </a:pPr>
+          </a:p>
+          <a:p>
+            <a:pPr>
+              <a:defRPr sz="2200" b="1">
+                <a:solidFill>
+                  <a:srgbClr val="34495E"/>
+                </a:solidFill>
+              </a:defRPr>
+            </a:pPr>
+            <a:r>
+              <a:t>[주제]   Git을 활용한 코드 관리 및 픽셀 단위 이미지 처리 실습</a:t>
+            </a:r>
+          </a:p>
+          <a:p>
+            <a:pPr>
+              <a:defRPr sz="800" b="0">
+                <a:solidFill>
+                  <a:srgbClr val="333333"/>
+                </a:solidFill>
+              </a:defRPr>
+            </a:pPr>
+          </a:p>
+          <a:p>
+            <a:pPr>
+              <a:defRPr sz="2200" b="1">
+                <a:solidFill>
+                  <a:srgbClr val="34495E"/>
+                </a:solidFill>
+              </a:defRPr>
+            </a:pPr>
+            <a:r>
+              <a:t>[요청내용]</a:t>
+            </a:r>
+          </a:p>
+          <a:p>
+            <a:pPr>
+              <a:defRPr sz="1800" b="0">
+                <a:solidFill>
+                  <a:srgbClr val="333333"/>
+                </a:solidFill>
+              </a:defRPr>
+            </a:pPr>
+            <a:r>
+              <a:t>1. Git 저장소 구성 및 실습</a:t>
+            </a:r>
+          </a:p>
+          <a:p>
+            <a:pPr>
+              <a:defRPr sz="1600" b="0">
+                <a:solidFill>
+                  <a:srgbClr val="555555"/>
+                </a:solidFill>
+              </a:defRPr>
+            </a:pPr>
+            <a:r>
+              <a:t>    - GitHub 저장소 생성, 로컬 연동, 브랜치 관리</a:t>
+            </a:r>
+          </a:p>
+          <a:p>
+            <a:pPr>
+              <a:defRPr sz="1800" b="0">
+                <a:solidFill>
+                  <a:srgbClr val="333333"/>
+                </a:solidFill>
+              </a:defRPr>
+            </a:pPr>
+            <a:r>
+              <a:t>2. 픽셀 단위 이미지 처리 코드 작성</a:t>
+            </a:r>
+          </a:p>
+          <a:p>
+            <a:pPr>
+              <a:defRPr sz="1600" b="0">
+                <a:solidFill>
+                  <a:srgbClr val="555555"/>
+                </a:solidFill>
+              </a:defRPr>
+            </a:pPr>
+            <a:r>
+              <a:t>    - OpenCV로 이미지 로드, HSV 변환, 특정 색상 필터링</a:t>
+            </a:r>
+          </a:p>
+          <a:p>
+            <a:pPr>
+              <a:defRPr sz="1800" b="0">
+                <a:solidFill>
+                  <a:srgbClr val="333333"/>
+                </a:solidFill>
+              </a:defRPr>
+            </a:pPr>
+            <a:r>
+              <a:t>3. Git 코드 관리 및 제출</a:t>
+            </a:r>
+          </a:p>
+          <a:p>
+            <a:pPr>
+              <a:defRPr sz="1600" b="0">
+                <a:solidFill>
+                  <a:srgbClr val="555555"/>
+                </a:solidFill>
+              </a:defRPr>
+            </a:pPr>
+            <a:r>
+              <a:t>    - commit, push, PR 생성, merge</a:t>
             </a:r>
           </a:p>
         </p:txBody>
@@ -4701,14 +3475,57 @@
       <p:grpSpPr/>
       <p:sp>
         <p:nvSpPr>
-          <p:cNvPr id="2" name="TextBox 1"/>
+          <p:cNvPr id="2" name="Rectangle 1"/>
+          <p:cNvSpPr/>
+          <p:nvPr/>
+        </p:nvSpPr>
+        <p:spPr>
+          <a:xfrm>
+            <a:off x="0" y="0"/>
+            <a:ext cx="12191695" cy="1005840"/>
+          </a:xfrm>
+          <a:prstGeom prst="rect">
+            <a:avLst/>
+          </a:prstGeom>
+          <a:solidFill>
+            <a:srgbClr val="34495E"/>
+          </a:solidFill>
+          <a:ln>
+            <a:noFill/>
+          </a:ln>
+        </p:spPr>
+        <p:style>
+          <a:lnRef idx="1">
+            <a:schemeClr val="accent1"/>
+          </a:lnRef>
+          <a:fillRef idx="3">
+            <a:schemeClr val="accent1"/>
+          </a:fillRef>
+          <a:effectRef idx="2">
+            <a:schemeClr val="accent1"/>
+          </a:effectRef>
+          <a:fontRef idx="minor">
+            <a:schemeClr val="lt1"/>
+          </a:fontRef>
+        </p:style>
+        <p:txBody>
+          <a:bodyPr rtlCol="0" anchor="ctr"/>
+          <a:lstStyle/>
+          <a:p>
+            <a:pPr algn="ctr"/>
+          </a:p>
+        </p:txBody>
+      </p:sp>
+      <p:sp>
+        <p:nvSpPr>
+          <p:cNvPr id="3" name="TextBox 2"/>
           <p:cNvSpPr txBox="1"/>
           <p:nvPr/>
         </p:nvSpPr>
         <p:spPr>
           <a:xfrm>
-            <a:off x="914400" y="457200"/>
-            <a:ext cx="10058400" cy="1097280"/>
+            <a:off x="914400" y="137160"/>
+            <a:ext cx="10058400" cy="731520"/>
           </a:xfrm>
           <a:prstGeom prst="rect">
             <a:avLst/>
@@ -4722,27 +3539,27 @@
           <a:lstStyle/>
           <a:p>
             <a:pPr>
-              <a:defRPr sz="4000" b="1">
-                <a:solidFill>
-                  <a:srgbClr val="333333"/>
-                </a:solidFill>
-              </a:defRPr>
-            </a:pPr>
-            <a:r>
-              <a:t>Git 워크플로우</a:t>
-            </a:r>
-          </a:p>
-        </p:txBody>
-      </p:sp>
-      <p:sp>
-        <p:nvSpPr>
-          <p:cNvPr id="3" name="TextBox 2"/>
+              <a:defRPr sz="3200" b="1">
+                <a:solidFill>
+                  <a:srgbClr val="FFFFFF"/>
+                </a:solidFill>
+              </a:defRPr>
+            </a:pPr>
+            <a:r>
+              <a:t>Git 저장소 구성 &amp; Branch 실습</a:t>
+            </a:r>
+          </a:p>
+        </p:txBody>
+      </p:sp>
+      <p:sp>
+        <p:nvSpPr>
+          <p:cNvPr id="4" name="TextBox 3"/>
           <p:cNvSpPr txBox="1"/>
           <p:nvPr/>
         </p:nvSpPr>
         <p:spPr>
           <a:xfrm>
-            <a:off x="1371600" y="1828800"/>
+            <a:off x="1371600" y="1371600"/>
             <a:ext cx="9144000" cy="4114800"/>
           </a:xfrm>
           <a:prstGeom prst="rect">
@@ -4758,31 +3575,145 @@
           <a:p/>
           <a:p>
             <a:pPr>
-              <a:defRPr sz="2000" b="0">
+              <a:defRPr sz="2200" b="1">
+                <a:solidFill>
+                  <a:srgbClr val="34495E"/>
+                </a:solidFill>
+              </a:defRPr>
+            </a:pPr>
+            <a:r>
+              <a:t>1.1 GitHub 저장소 생성</a:t>
+            </a:r>
+          </a:p>
+          <a:p>
+            <a:pPr>
+              <a:defRPr sz="1600" b="0">
+                <a:solidFill>
+                  <a:srgbClr val="555555"/>
+                </a:solidFill>
+              </a:defRPr>
+            </a:pPr>
+            <a:r>
+              <a:t>    "초기화 안 함" 상태로 생성 (No README / No .gitignore)</a:t>
+            </a:r>
+          </a:p>
+          <a:p>
+            <a:pPr>
+              <a:defRPr sz="1600" b="0">
+                <a:solidFill>
+                  <a:srgbClr val="555555"/>
+                </a:solidFill>
+              </a:defRPr>
+            </a:pPr>
+            <a:r>
+              <a:t>    저장소 URL 복사 → 로컬 환경에 연동</a:t>
+            </a:r>
+          </a:p>
+          <a:p>
+            <a:pPr>
+              <a:defRPr sz="800" b="0">
                 <a:solidFill>
                   <a:srgbClr val="333333"/>
                 </a:solidFill>
               </a:defRPr>
             </a:pPr>
-            <a:r>
-              <a:t>[저장소] jsm0308/Bootcamp-CV</a:t>
-            </a:r>
-          </a:p>
-          <a:p>
-            <a:pPr>
-              <a:defRPr sz="2000" b="0">
+          </a:p>
+          <a:p>
+            <a:pPr>
+              <a:defRPr sz="2200" b="1">
+                <a:solidFill>
+                  <a:srgbClr val="34495E"/>
+                </a:solidFill>
+              </a:defRPr>
+            </a:pPr>
+            <a:r>
+              <a:t>1.2 로컬 환경 Git 연동</a:t>
+            </a:r>
+          </a:p>
+          <a:p>
+            <a:pPr>
+              <a:defRPr sz="1600" b="0">
+                <a:solidFill>
+                  <a:srgbClr val="2980B9"/>
+                </a:solidFill>
+              </a:defRPr>
+            </a:pPr>
+            <a:r>
+              <a:t>    &gt; git init</a:t>
+            </a:r>
+          </a:p>
+          <a:p>
+            <a:pPr>
+              <a:defRPr sz="1600" b="0">
+                <a:solidFill>
+                  <a:srgbClr val="2980B9"/>
+                </a:solidFill>
+              </a:defRPr>
+            </a:pPr>
+            <a:r>
+              <a:t>    &gt; git clone [저장소 URL]</a:t>
+            </a:r>
+          </a:p>
+          <a:p>
+            <a:pPr>
+              <a:defRPr sz="1600" b="0">
+                <a:solidFill>
+                  <a:srgbClr val="2980B9"/>
+                </a:solidFill>
+              </a:defRPr>
+            </a:pPr>
+            <a:r>
+              <a:t>    &gt; git pull origin main</a:t>
+            </a:r>
+          </a:p>
+          <a:p>
+            <a:pPr>
+              <a:defRPr sz="800" b="0">
                 <a:solidFill>
                   <a:srgbClr val="333333"/>
                 </a:solidFill>
               </a:defRPr>
             </a:pPr>
-            <a:r>
-              <a:t>[브랜치] feature/image-processing -&gt; PR -&gt; main 병합</a:t>
-            </a:r>
-          </a:p>
-          <a:p>
-            <a:pPr>
-              <a:defRPr sz="1000" b="0">
+          </a:p>
+          <a:p>
+            <a:pPr>
+              <a:defRPr sz="2200" b="1">
+                <a:solidFill>
+                  <a:srgbClr val="34495E"/>
+                </a:solidFill>
+              </a:defRPr>
+            </a:pPr>
+            <a:r>
+              <a:t>2. Branch 및 Commit 실습</a:t>
+            </a:r>
+          </a:p>
+          <a:p>
+            <a:pPr>
+              <a:defRPr sz="1600" b="0">
+                <a:solidFill>
+                  <a:srgbClr val="2980B9"/>
+                </a:solidFill>
+              </a:defRPr>
+            </a:pPr>
+            <a:r>
+              <a:t>    &gt; git branch feature/image-processing</a:t>
+            </a:r>
+          </a:p>
+          <a:p>
+            <a:pPr>
+              <a:defRPr sz="1600" b="0">
+                <a:solidFill>
+                  <a:srgbClr val="2980B9"/>
+                </a:solidFill>
+              </a:defRPr>
+            </a:pPr>
+            <a:r>
+              <a:t>    &gt; git checkout feature/image-processing</a:t>
+            </a:r>
+          </a:p>
+          <a:p>
+            <a:pPr>
+              <a:defRPr sz="800" b="0">
                 <a:solidFill>
                   <a:srgbClr val="333333"/>
                 </a:solidFill>
@@ -4791,95 +3722,14 @@
           </a:p>
           <a:p>
             <a:pPr>
-              <a:defRPr sz="2200" b="1">
-                <a:solidFill>
-                  <a:srgbClr val="333333"/>
-                </a:solidFill>
-              </a:defRPr>
-            </a:pPr>
-            <a:r>
-              <a:t>사용한 명령어</a:t>
-            </a:r>
-          </a:p>
-          <a:p>
-            <a:pPr>
-              <a:defRPr sz="1800" b="0">
-                <a:solidFill>
-                  <a:srgbClr val="555555"/>
-                </a:solidFill>
-              </a:defRPr>
-            </a:pPr>
-            <a:r>
-              <a:t>  git branch feature/image-processing</a:t>
-            </a:r>
-          </a:p>
-          <a:p>
-            <a:pPr>
-              <a:defRPr sz="1800" b="0">
-                <a:solidFill>
-                  <a:srgbClr val="555555"/>
-                </a:solidFill>
-              </a:defRPr>
-            </a:pPr>
-            <a:r>
-              <a:t>  git checkout feature/image-processing</a:t>
-            </a:r>
-          </a:p>
-          <a:p>
-            <a:pPr>
-              <a:defRPr sz="1800" b="0">
-                <a:solidFill>
-                  <a:srgbClr val="555555"/>
-                </a:solidFill>
-              </a:defRPr>
-            </a:pPr>
-            <a:r>
-              <a:t>  git add &lt;file&gt;</a:t>
-            </a:r>
-          </a:p>
-          <a:p>
-            <a:pPr>
-              <a:defRPr sz="1800" b="0">
-                <a:solidFill>
-                  <a:srgbClr val="555555"/>
-                </a:solidFill>
-              </a:defRPr>
-            </a:pPr>
-            <a:r>
-              <a:t>  git commit -m "message"</a:t>
-            </a:r>
-          </a:p>
-          <a:p>
-            <a:pPr>
-              <a:defRPr sz="1800" b="0">
-                <a:solidFill>
-                  <a:srgbClr val="555555"/>
-                </a:solidFill>
-              </a:defRPr>
-            </a:pPr>
-            <a:r>
-              <a:t>  git push origin feature/image-processing</a:t>
-            </a:r>
-          </a:p>
-          <a:p>
-            <a:pPr>
-              <a:defRPr sz="1000" b="0">
-                <a:solidFill>
-                  <a:srgbClr val="333333"/>
-                </a:solidFill>
-              </a:defRPr>
-            </a:pPr>
-          </a:p>
-          <a:p>
-            <a:pPr>
-              <a:defRPr sz="2000" b="0">
+              <a:defRPr sz="1800" b="1">
                 <a:solidFill>
                   <a:srgbClr val="27AE60"/>
                 </a:solidFill>
               </a:defRPr>
             </a:pPr>
             <a:r>
-              <a:t>[결과] PR 생성 -&gt; Fast-forward merge 완료</a:t>
+              <a:t>[결과] jsm0308/Bootcamp-CV  +  feature/image-processing 브랜치</a:t>
             </a:r>
           </a:p>
         </p:txBody>
@@ -4904,14 +3754,57 @@
       <p:grpSpPr/>
       <p:sp>
         <p:nvSpPr>
-          <p:cNvPr id="2" name="TextBox 1"/>
+          <p:cNvPr id="2" name="Rectangle 1"/>
+          <p:cNvSpPr/>
+          <p:nvPr/>
+        </p:nvSpPr>
+        <p:spPr>
+          <a:xfrm>
+            <a:off x="0" y="0"/>
+            <a:ext cx="12191695" cy="1005840"/>
+          </a:xfrm>
+          <a:prstGeom prst="rect">
+            <a:avLst/>
+          </a:prstGeom>
+          <a:solidFill>
+            <a:srgbClr val="34495E"/>
+          </a:solidFill>
+          <a:ln>
+            <a:noFill/>
+          </a:ln>
+        </p:spPr>
+        <p:style>
+          <a:lnRef idx="1">
+            <a:schemeClr val="accent1"/>
+          </a:lnRef>
+          <a:fillRef idx="3">
+            <a:schemeClr val="accent1"/>
+          </a:fillRef>
+          <a:effectRef idx="2">
+            <a:schemeClr val="accent1"/>
+          </a:effectRef>
+          <a:fontRef idx="minor">
+            <a:schemeClr val="lt1"/>
+          </a:fontRef>
+        </p:style>
+        <p:txBody>
+          <a:bodyPr rtlCol="0" anchor="ctr"/>
+          <a:lstStyle/>
+          <a:p>
+            <a:pPr algn="ctr"/>
+          </a:p>
+        </p:txBody>
+      </p:sp>
+      <p:sp>
+        <p:nvSpPr>
+          <p:cNvPr id="3" name="TextBox 2"/>
           <p:cNvSpPr txBox="1"/>
           <p:nvPr/>
         </p:nvSpPr>
         <p:spPr>
           <a:xfrm>
-            <a:off x="914400" y="457200"/>
-            <a:ext cx="10058400" cy="1097280"/>
+            <a:off x="914400" y="137160"/>
+            <a:ext cx="10058400" cy="731520"/>
           </a:xfrm>
           <a:prstGeom prst="rect">
             <a:avLst/>
@@ -4925,27 +3818,27 @@
           <a:lstStyle/>
           <a:p>
             <a:pPr>
-              <a:defRPr sz="4000" b="1">
-                <a:solidFill>
-                  <a:srgbClr val="333333"/>
-                </a:solidFill>
-              </a:defRPr>
-            </a:pPr>
-            <a:r>
-              <a:t>프로젝트 구조</a:t>
-            </a:r>
-          </a:p>
-        </p:txBody>
-      </p:sp>
-      <p:sp>
-        <p:nvSpPr>
-          <p:cNvPr id="3" name="TextBox 2"/>
+              <a:defRPr sz="3200" b="1">
+                <a:solidFill>
+                  <a:srgbClr val="FFFFFF"/>
+                </a:solidFill>
+              </a:defRPr>
+            </a:pPr>
+            <a:r>
+              <a:t>이미지 처리 코드 작성</a:t>
+            </a:r>
+          </a:p>
+        </p:txBody>
+      </p:sp>
+      <p:sp>
+        <p:nvSpPr>
+          <p:cNvPr id="4" name="TextBox 3"/>
           <p:cNvSpPr txBox="1"/>
           <p:nvPr/>
         </p:nvSpPr>
         <p:spPr>
           <a:xfrm>
-            <a:off x="1371600" y="1828800"/>
+            <a:off x="1371600" y="1371600"/>
             <a:ext cx="9144000" cy="4114800"/>
           </a:xfrm>
           <a:prstGeom prst="rect">
@@ -4963,12 +3856,33 @@
             <a:pPr>
               <a:defRPr sz="2000" b="1">
                 <a:solidFill>
+                  <a:srgbClr val="34495E"/>
+                </a:solidFill>
+              </a:defRPr>
+            </a:pPr>
+            <a:r>
+              <a:t>OpenCV로 이미지 로드 → HSV 색상 공간 변환 → 빨간색 필터링</a:t>
+            </a:r>
+          </a:p>
+          <a:p>
+            <a:pPr>
+              <a:defRPr sz="600" b="0">
+                <a:solidFill>
                   <a:srgbClr val="333333"/>
                 </a:solidFill>
               </a:defRPr>
             </a:pPr>
-            <a:r>
-              <a:t>week 1/</a:t>
+          </a:p>
+          <a:p>
+            <a:pPr>
+              <a:defRPr sz="1800" b="0">
+                <a:solidFill>
+                  <a:srgbClr val="333333"/>
+                </a:solidFill>
+              </a:defRPr>
+            </a:pPr>
+            <a:r>
+              <a:t>사용 함수:</a:t>
             </a:r>
           </a:p>
           <a:p>
@@ -4980,103 +3894,406 @@
               </a:defRPr>
             </a:pPr>
             <a:r>
-              <a:t>├── requirements.txt          &lt;- 공통 패키지</a:t>
-            </a:r>
-          </a:p>
-          <a:p>
-            <a:pPr>
-              <a:defRPr sz="1700" b="1">
+              <a:t>  cv2.imread()         이미지 로드</a:t>
+            </a:r>
+          </a:p>
+          <a:p>
+            <a:pPr>
+              <a:defRPr sz="1600" b="0">
+                <a:solidFill>
+                  <a:srgbClr val="555555"/>
+                </a:solidFill>
+              </a:defRPr>
+            </a:pPr>
+            <a:r>
+              <a:t>  cv2.cvtColor()       BGR → HSV 변환</a:t>
+            </a:r>
+          </a:p>
+          <a:p>
+            <a:pPr>
+              <a:defRPr sz="1600" b="0">
+                <a:solidFill>
+                  <a:srgbClr val="555555"/>
+                </a:solidFill>
+              </a:defRPr>
+            </a:pPr>
+            <a:r>
+              <a:t>  cv2.inRange()        빨간색 범위 마스킹 (2개)</a:t>
+            </a:r>
+          </a:p>
+          <a:p>
+            <a:pPr>
+              <a:defRPr sz="1600" b="0">
+                <a:solidFill>
+                  <a:srgbClr val="E74C3C"/>
+                </a:solidFill>
+              </a:defRPr>
+            </a:pPr>
+            <a:r>
+              <a:t>  cv2.bitwise_or()     두 마스크 합치기</a:t>
+            </a:r>
+          </a:p>
+          <a:p>
+            <a:pPr>
+              <a:defRPr sz="1600" b="0">
+                <a:solidFill>
+                  <a:srgbClr val="555555"/>
+                </a:solidFill>
+              </a:defRPr>
+            </a:pPr>
+            <a:r>
+              <a:t>  cv2.bitwise_and()    원본 × 마스크 → 결과</a:t>
+            </a:r>
+          </a:p>
+          <a:p>
+            <a:pPr>
+              <a:defRPr sz="1600" b="0">
+                <a:solidFill>
+                  <a:srgbClr val="555555"/>
+                </a:solidFill>
+              </a:defRPr>
+            </a:pPr>
+            <a:r>
+              <a:t>  cv2.imwrite()        결과 저장</a:t>
+            </a:r>
+          </a:p>
+          <a:p>
+            <a:pPr>
+              <a:defRPr sz="600" b="0">
                 <a:solidFill>
                   <a:srgbClr val="333333"/>
                 </a:solidFill>
               </a:defRPr>
             </a:pPr>
-            <a:r>
-              <a:t>├── git/                      &lt;- 핵심 과제</a:t>
-            </a:r>
-          </a:p>
-          <a:p>
-            <a:pPr>
-              <a:defRPr sz="1600" b="0">
+          </a:p>
+          <a:p>
+            <a:pPr>
+              <a:defRPr sz="1800" b="0">
+                <a:solidFill>
+                  <a:srgbClr val="E74C3C"/>
+                </a:solidFill>
+              </a:defRPr>
+            </a:pPr>
+            <a:r>
+              <a:t>[주의] mask1 + mask2 → cv2.bitwise_or 로 교체</a:t>
+            </a:r>
+          </a:p>
+          <a:p>
+            <a:pPr>
+              <a:defRPr sz="1400" b="0">
                 <a:solidFill>
                   <a:srgbClr val="555555"/>
                 </a:solidFill>
               </a:defRPr>
             </a:pPr>
             <a:r>
-              <a:t>│   ├── red.py                 # HSV 빨간색 검출</a:t>
-            </a:r>
-          </a:p>
-          <a:p>
-            <a:pPr>
-              <a:defRPr sz="1600" b="0">
+              <a:t>  uint8에서 255+255=510 overflow 방지</a:t>
+            </a:r>
+          </a:p>
+        </p:txBody>
+      </p:sp>
+      <p:sp>
+        <p:nvSpPr>
+          <p:cNvPr id="5" name="TextBox 4"/>
+          <p:cNvSpPr txBox="1"/>
+          <p:nvPr/>
+        </p:nvSpPr>
+        <p:spPr>
+          <a:xfrm>
+            <a:off x="6400800" y="1371600"/>
+            <a:ext cx="4572000" cy="4572000"/>
+          </a:xfrm>
+          <a:prstGeom prst="rect">
+            <a:avLst/>
+          </a:prstGeom>
+          <a:noFill/>
+        </p:spPr>
+        <p:txBody>
+          <a:bodyPr wrap="square">
+            <a:spAutoFit/>
+          </a:bodyPr>
+          <a:lstStyle/>
+          <a:p/>
+          <a:p>
+            <a:pPr>
+              <a:defRPr sz="1600" b="1">
+                <a:solidFill>
+                  <a:srgbClr val="34495E"/>
+                </a:solidFill>
+              </a:defRPr>
+            </a:pPr>
+            <a:r>
+              <a:t>Core Code</a:t>
+            </a:r>
+          </a:p>
+          <a:p>
+            <a:pPr>
+              <a:defRPr sz="1400" b="0">
                 <a:solidFill>
                   <a:srgbClr val="555555"/>
                 </a:solidFill>
               </a:defRPr>
             </a:pPr>
             <a:r>
-              <a:t>│   └── red_filtered.jpg       # 결과물</a:t>
-            </a:r>
-          </a:p>
-          <a:p>
-            <a:pPr>
-              <a:defRPr sz="1700" b="1">
-                <a:solidFill>
-                  <a:srgbClr val="333333"/>
-                </a:solidFill>
-              </a:defRPr>
-            </a:pPr>
-            <a:r>
-              <a:t>└── huggingface/              &lt;- 추가 과제</a:t>
-            </a:r>
-          </a:p>
-          <a:p>
-            <a:pPr>
-              <a:defRPr sz="1600" b="0">
+              <a:t>import cv2, numpy as np</a:t>
+            </a:r>
+          </a:p>
+          <a:p>
+            <a:pPr>
+              <a:defRPr sz="1400" b="0">
                 <a:solidFill>
                   <a:srgbClr val="555555"/>
                 </a:solidFill>
               </a:defRPr>
             </a:pPr>
             <a:r>
-              <a:t>    ├── dataset.py             # Food101 + pandas</a:t>
-            </a:r>
-          </a:p>
-          <a:p>
-            <a:pPr>
-              <a:defRPr sz="1600" b="0">
+              <a:t>image = cv2.imread('sample.jpg')</a:t>
+            </a:r>
+          </a:p>
+          <a:p>
+            <a:pPr>
+              <a:defRPr sz="1400" b="0">
                 <a:solidFill>
                   <a:srgbClr val="555555"/>
                 </a:solidFill>
               </a:defRPr>
             </a:pPr>
             <a:r>
-              <a:t>    ├── image_preprocessing.py # 전처리 파이프라인</a:t>
-            </a:r>
-          </a:p>
-          <a:p>
-            <a:pPr>
-              <a:defRPr sz="1600" b="0">
+              <a:t>hsv = cv2.cvtColor(image,</a:t>
+            </a:r>
+          </a:p>
+          <a:p>
+            <a:pPr>
+              <a:defRPr sz="1400" b="0">
                 <a:solidFill>
                   <a:srgbClr val="555555"/>
                 </a:solidFill>
               </a:defRPr>
             </a:pPr>
             <a:r>
-              <a:t>    ├── data/                  # 원본 5장</a:t>
-            </a:r>
-          </a:p>
-          <a:p>
-            <a:pPr>
-              <a:defRPr sz="1600" b="0">
+              <a:t>          cv2.COLOR_BGR2HSV)</a:t>
+            </a:r>
+          </a:p>
+          <a:p>
+            <a:pPr>
+              <a:defRPr sz="1400" b="0">
                 <a:solidFill>
                   <a:srgbClr val="555555"/>
                 </a:solidFill>
               </a:defRPr>
             </a:pPr>
-            <a:r>
-              <a:t>    └── preprocessed_samples/  # 전처리+증강 20장</a:t>
+          </a:p>
+          <a:p>
+            <a:pPr>
+              <a:defRPr sz="1400" b="0">
+                <a:solidFill>
+                  <a:srgbClr val="E74C3C"/>
+                </a:solidFill>
+              </a:defRPr>
+            </a:pPr>
+            <a:r>
+              <a:t>lower_red1 = [0, 120, 70]</a:t>
+            </a:r>
+          </a:p>
+          <a:p>
+            <a:pPr>
+              <a:defRPr sz="1400" b="0">
+                <a:solidFill>
+                  <a:srgbClr val="E74C3C"/>
+                </a:solidFill>
+              </a:defRPr>
+            </a:pPr>
+            <a:r>
+              <a:t>upper_red1 = [10, 255, 255]</a:t>
+            </a:r>
+          </a:p>
+          <a:p>
+            <a:pPr>
+              <a:defRPr sz="1400" b="0">
+                <a:solidFill>
+                  <a:srgbClr val="E74C3C"/>
+                </a:solidFill>
+              </a:defRPr>
+            </a:pPr>
+            <a:r>
+              <a:t>lower_red2 = [170, 120, 70]</a:t>
+            </a:r>
+          </a:p>
+          <a:p>
+            <a:pPr>
+              <a:defRPr sz="1400" b="0">
+                <a:solidFill>
+                  <a:srgbClr val="E74C3C"/>
+                </a:solidFill>
+              </a:defRPr>
+            </a:pPr>
+            <a:r>
+              <a:t>upper_red2 = [180, 255, 255]</a:t>
+            </a:r>
+          </a:p>
+          <a:p>
+            <a:pPr>
+              <a:defRPr sz="1400" b="0">
+                <a:solidFill>
+                  <a:srgbClr val="555555"/>
+                </a:solidFill>
+              </a:defRPr>
+            </a:pPr>
+          </a:p>
+          <a:p>
+            <a:pPr>
+              <a:defRPr sz="1400" b="0">
+                <a:solidFill>
+                  <a:srgbClr val="555555"/>
+                </a:solidFill>
+              </a:defRPr>
+            </a:pPr>
+            <a:r>
+              <a:t>mask1 = cv2.inRange(hsv, ...)</a:t>
+            </a:r>
+          </a:p>
+          <a:p>
+            <a:pPr>
+              <a:defRPr sz="1400" b="0">
+                <a:solidFill>
+                  <a:srgbClr val="555555"/>
+                </a:solidFill>
+              </a:defRPr>
+            </a:pPr>
+            <a:r>
+              <a:t>mask2 = cv2.inRange(hsv, ...)</a:t>
+            </a:r>
+          </a:p>
+          <a:p>
+            <a:pPr>
+              <a:defRPr sz="1400" b="0">
+                <a:solidFill>
+                  <a:srgbClr val="555555"/>
+                </a:solidFill>
+              </a:defRPr>
+            </a:pPr>
+            <a:r>
+              <a:t>mask = cv2.bitwise_or(m1, m2)</a:t>
+            </a:r>
+          </a:p>
+          <a:p>
+            <a:pPr>
+              <a:defRPr sz="1400" b="0">
+                <a:solidFill>
+                  <a:srgbClr val="555555"/>
+                </a:solidFill>
+              </a:defRPr>
+            </a:pPr>
+            <a:r>
+              <a:t>result = cv2.bitwise_and(</a:t>
+            </a:r>
+          </a:p>
+          <a:p>
+            <a:pPr>
+              <a:defRPr sz="1400" b="0">
+                <a:solidFill>
+                  <a:srgbClr val="555555"/>
+                </a:solidFill>
+              </a:defRPr>
+            </a:pPr>
+            <a:r>
+              <a:t>    image,image, mask=mask)</a:t>
+            </a:r>
+          </a:p>
+          <a:p>
+            <a:pPr>
+              <a:defRPr sz="1400" b="0">
+                <a:solidFill>
+                  <a:srgbClr val="555555"/>
+                </a:solidFill>
+              </a:defRPr>
+            </a:pPr>
+            <a:r>
+              <a:t>cv2.imwrite(</a:t>
+            </a:r>
+          </a:p>
+          <a:p>
+            <a:pPr>
+              <a:defRPr sz="1400" b="0">
+                <a:solidFill>
+                  <a:srgbClr val="555555"/>
+                </a:solidFill>
+              </a:defRPr>
+            </a:pPr>
+            <a:r>
+              <a:t>    'red_filtered.jpg',</a:t>
+            </a:r>
+          </a:p>
+          <a:p>
+            <a:pPr>
+              <a:defRPr sz="1400" b="0">
+                <a:solidFill>
+                  <a:srgbClr val="555555"/>
+                </a:solidFill>
+              </a:defRPr>
+            </a:pPr>
+            <a:r>
+              <a:t>    result)</a:t>
+            </a:r>
+          </a:p>
+        </p:txBody>
+      </p:sp>
+      <p:pic>
+        <p:nvPicPr>
+          <p:cNvPr id="6" name="Picture 5" descr="jsm0308-Bootcamp-CV.png"/>
+          <p:cNvPicPr>
+            <a:picLocks noChangeAspect="1"/>
+          </p:cNvPicPr>
+          <p:nvPr/>
+        </p:nvPicPr>
+        <p:blipFill>
+          <a:blip r:embed="rId2"/>
+          <a:stretch>
+            <a:fillRect/>
+          </a:stretch>
+        </p:blipFill>
+        <p:spPr>
+          <a:xfrm>
+            <a:off x="7132320" y="2011680"/>
+            <a:ext cx="4114800" cy="1903095"/>
+          </a:xfrm>
+          <a:prstGeom prst="rect">
+            <a:avLst/>
+          </a:prstGeom>
+        </p:spPr>
+      </p:pic>
+      <p:sp>
+        <p:nvSpPr>
+          <p:cNvPr id="7" name="TextBox 6"/>
+          <p:cNvSpPr txBox="1"/>
+          <p:nvPr/>
+        </p:nvSpPr>
+        <p:spPr>
+          <a:xfrm>
+            <a:off x="1371600" y="5943600"/>
+            <a:ext cx="9144000" cy="457200"/>
+          </a:xfrm>
+          <a:prstGeom prst="rect">
+            <a:avLst/>
+          </a:prstGeom>
+          <a:noFill/>
+        </p:spPr>
+        <p:txBody>
+          <a:bodyPr wrap="square">
+            <a:spAutoFit/>
+          </a:bodyPr>
+          <a:lstStyle/>
+          <a:p/>
+          <a:p>
+            <a:pPr>
+              <a:defRPr sz="1400" b="0">
+                <a:solidFill>
+                  <a:srgbClr val="555555"/>
+                </a:solidFill>
+              </a:defRPr>
+            </a:pPr>
+            <a:r>
+              <a:t>POC: red.py는 추가 라이브러리 없이 OpenCV + NumPy만으로 구현</a:t>
             </a:r>
           </a:p>
         </p:txBody>
@@ -5092,14 +4309,6 @@
 <file path=ppt/slides/slide5.xml><?xml version="1.0" encoding="utf-8"?>
 <p:sld xmlns:a="http://schemas.openxmlformats.org/drawingml/2006/main" xmlns:p="http://schemas.openxmlformats.org/presentationml/2006/main" xmlns:r="http://schemas.openxmlformats.org/officeDocument/2006/relationships">
   <p:cSld>
-    <p:bg>
-      <p:bgPr>
-        <a:solidFill>
-          <a:srgbClr val="34495E"/>
-        </a:solidFill>
-        <a:effectLst/>
-      </p:bgPr>
-    </p:bg>
     <p:spTree>
       <p:nvGrpSpPr>
         <p:cNvPr id="1" name=""/>
@@ -5109,14 +4318,57 @@
       <p:grpSpPr/>
       <p:sp>
         <p:nvSpPr>
-          <p:cNvPr id="2" name="TextBox 1"/>
+          <p:cNvPr id="2" name="Rectangle 1"/>
+          <p:cNvSpPr/>
+          <p:nvPr/>
+        </p:nvSpPr>
+        <p:spPr>
+          <a:xfrm>
+            <a:off x="0" y="0"/>
+            <a:ext cx="12191695" cy="1005840"/>
+          </a:xfrm>
+          <a:prstGeom prst="rect">
+            <a:avLst/>
+          </a:prstGeom>
+          <a:solidFill>
+            <a:srgbClr val="34495E"/>
+          </a:solidFill>
+          <a:ln>
+            <a:noFill/>
+          </a:ln>
+        </p:spPr>
+        <p:style>
+          <a:lnRef idx="1">
+            <a:schemeClr val="accent1"/>
+          </a:lnRef>
+          <a:fillRef idx="3">
+            <a:schemeClr val="accent1"/>
+          </a:fillRef>
+          <a:effectRef idx="2">
+            <a:schemeClr val="accent1"/>
+          </a:effectRef>
+          <a:fontRef idx="minor">
+            <a:schemeClr val="lt1"/>
+          </a:fontRef>
+        </p:style>
+        <p:txBody>
+          <a:bodyPr rtlCol="0" anchor="ctr"/>
+          <a:lstStyle/>
+          <a:p>
+            <a:pPr algn="ctr"/>
+          </a:p>
+        </p:txBody>
+      </p:sp>
+      <p:sp>
+        <p:nvSpPr>
+          <p:cNvPr id="3" name="TextBox 2"/>
           <p:cNvSpPr txBox="1"/>
           <p:nvPr/>
         </p:nvSpPr>
         <p:spPr>
           <a:xfrm>
-            <a:off x="914400" y="2286000"/>
-            <a:ext cx="10058400" cy="1828800"/>
+            <a:off x="914400" y="137160"/>
+            <a:ext cx="10058400" cy="731520"/>
           </a:xfrm>
           <a:prstGeom prst="rect">
             <a:avLst/>
@@ -5128,29 +4380,202 @@
             <a:spAutoFit/>
           </a:bodyPr>
           <a:lstStyle/>
+          <a:p>
+            <a:pPr>
+              <a:defRPr sz="3200" b="1">
+                <a:solidFill>
+                  <a:srgbClr val="FFFFFF"/>
+                </a:solidFill>
+              </a:defRPr>
+            </a:pPr>
+            <a:r>
+              <a:t>Git 최종 제출 &amp; Pull Request</a:t>
+            </a:r>
+          </a:p>
+        </p:txBody>
+      </p:sp>
+      <p:sp>
+        <p:nvSpPr>
+          <p:cNvPr id="4" name="TextBox 3"/>
+          <p:cNvSpPr txBox="1"/>
+          <p:nvPr/>
+        </p:nvSpPr>
+        <p:spPr>
+          <a:xfrm>
+            <a:off x="1371600" y="1371600"/>
+            <a:ext cx="9144000" cy="4114800"/>
+          </a:xfrm>
+          <a:prstGeom prst="rect">
+            <a:avLst/>
+          </a:prstGeom>
+          <a:noFill/>
+        </p:spPr>
+        <p:txBody>
+          <a:bodyPr wrap="square">
+            <a:spAutoFit/>
+          </a:bodyPr>
+          <a:lstStyle/>
           <a:p/>
           <a:p>
             <a:pPr>
-              <a:defRPr sz="3800" b="1">
-                <a:solidFill>
-                  <a:srgbClr val="FFFFFF"/>
-                </a:solidFill>
-              </a:defRPr>
-            </a:pPr>
-            <a:r>
-              <a:t>Part 2. OpenCV 픽셀 처리</a:t>
-            </a:r>
-          </a:p>
-          <a:p>
-            <a:pPr>
-              <a:defRPr sz="2200" b="0">
-                <a:solidFill>
-                  <a:srgbClr val="BBBBBB"/>
-                </a:solidFill>
-              </a:defRPr>
-            </a:pPr>
-            <a:r>
-              <a:t>HSV 색상 공간 · 빨간색(Red) 영역 검출</a:t>
+              <a:defRPr sz="2200" b="1">
+                <a:solidFill>
+                  <a:srgbClr val="34495E"/>
+                </a:solidFill>
+              </a:defRPr>
+            </a:pPr>
+            <a:r>
+              <a:t>4. Git 최종 코드 제출</a:t>
+            </a:r>
+          </a:p>
+          <a:p>
+            <a:pPr>
+              <a:defRPr sz="1600" b="0">
+                <a:solidFill>
+                  <a:srgbClr val="555555"/>
+                </a:solidFill>
+              </a:defRPr>
+            </a:pPr>
+            <a:r>
+              <a:t>    &gt; git status                  # 변경 사항 확인</a:t>
+            </a:r>
+          </a:p>
+          <a:p>
+            <a:pPr>
+              <a:defRPr sz="1600" b="0">
+                <a:solidFill>
+                  <a:srgbClr val="555555"/>
+                </a:solidFill>
+              </a:defRPr>
+            </a:pPr>
+            <a:r>
+              <a:t>    &gt; git add .                   # 변경된 파일 추가</a:t>
+            </a:r>
+          </a:p>
+          <a:p>
+            <a:pPr>
+              <a:defRPr sz="1600" b="0">
+                <a:solidFill>
+                  <a:srgbClr val="555555"/>
+                </a:solidFill>
+              </a:defRPr>
+            </a:pPr>
+            <a:r>
+              <a:t>    &gt; git commit -m "..message.."  # 커밋</a:t>
+            </a:r>
+          </a:p>
+          <a:p>
+            <a:pPr>
+              <a:defRPr sz="1600" b="0">
+                <a:solidFill>
+                  <a:srgbClr val="555555"/>
+                </a:solidFill>
+              </a:defRPr>
+            </a:pPr>
+            <a:r>
+              <a:t>    &gt; git push origin [...]       # 원격 저장소 업로드</a:t>
+            </a:r>
+          </a:p>
+          <a:p>
+            <a:pPr>
+              <a:defRPr sz="800" b="0">
+                <a:solidFill>
+                  <a:srgbClr val="333333"/>
+                </a:solidFill>
+              </a:defRPr>
+            </a:pPr>
+          </a:p>
+          <a:p>
+            <a:pPr>
+              <a:defRPr sz="2200" b="1">
+                <a:solidFill>
+                  <a:srgbClr val="34495E"/>
+                </a:solidFill>
+              </a:defRPr>
+            </a:pPr>
+            <a:r>
+              <a:t>5. Pull Request &amp; Merge</a:t>
+            </a:r>
+          </a:p>
+          <a:p>
+            <a:pPr>
+              <a:defRPr sz="1600" b="0">
+                <a:solidFill>
+                  <a:srgbClr val="555555"/>
+                </a:solidFill>
+              </a:defRPr>
+            </a:pPr>
+            <a:r>
+              <a:t>    GitHub에서 PR 생성 → 리뷰어 추가 → 코드 리뷰</a:t>
+            </a:r>
+          </a:p>
+          <a:p>
+            <a:pPr>
+              <a:defRPr sz="1600" b="0">
+                <a:solidFill>
+                  <a:srgbClr val="555555"/>
+                </a:solidFill>
+              </a:defRPr>
+            </a:pPr>
+            <a:r>
+              <a:t>    &gt; git checkout main           # main 브랜치로 이동</a:t>
+            </a:r>
+          </a:p>
+          <a:p>
+            <a:pPr>
+              <a:defRPr sz="1600" b="0">
+                <a:solidFill>
+                  <a:srgbClr val="555555"/>
+                </a:solidFill>
+              </a:defRPr>
+            </a:pPr>
+            <a:r>
+              <a:t>    &gt; git merge [브랜치 이름]     # 변경 내용 병합</a:t>
+            </a:r>
+          </a:p>
+          <a:p>
+            <a:pPr>
+              <a:defRPr sz="1600" b="0">
+                <a:solidFill>
+                  <a:srgbClr val="555555"/>
+                </a:solidFill>
+              </a:defRPr>
+            </a:pPr>
+            <a:r>
+              <a:t>    &gt; git push origin main        # 최종 푸시</a:t>
+            </a:r>
+          </a:p>
+          <a:p>
+            <a:pPr>
+              <a:defRPr sz="800" b="0">
+                <a:solidFill>
+                  <a:srgbClr val="333333"/>
+                </a:solidFill>
+              </a:defRPr>
+            </a:pPr>
+          </a:p>
+          <a:p>
+            <a:pPr>
+              <a:defRPr sz="1800" b="1">
+                <a:solidFill>
+                  <a:srgbClr val="27AE60"/>
+                </a:solidFill>
+              </a:defRPr>
+            </a:pPr>
+            <a:r>
+              <a:t>[결과] PR #1 생성 → main Fast-forward merge 완료</a:t>
+            </a:r>
+          </a:p>
+          <a:p>
+            <a:pPr>
+              <a:defRPr sz="1400" b="0">
+                <a:solidFill>
+                  <a:srgbClr val="2980B9"/>
+                </a:solidFill>
+              </a:defRPr>
+            </a:pPr>
+            <a:r>
+              <a:t>        https://github.com/jsm0308/Bootcamp-CV/pull/1</a:t>
             </a:r>
           </a:p>
         </p:txBody>
@@ -5175,14 +4600,57 @@
       <p:grpSpPr/>
       <p:sp>
         <p:nvSpPr>
-          <p:cNvPr id="2" name="TextBox 1"/>
+          <p:cNvPr id="2" name="Rectangle 1"/>
+          <p:cNvSpPr/>
+          <p:nvPr/>
+        </p:nvSpPr>
+        <p:spPr>
+          <a:xfrm>
+            <a:off x="0" y="0"/>
+            <a:ext cx="12191695" cy="1005840"/>
+          </a:xfrm>
+          <a:prstGeom prst="rect">
+            <a:avLst/>
+          </a:prstGeom>
+          <a:solidFill>
+            <a:srgbClr val="34495E"/>
+          </a:solidFill>
+          <a:ln>
+            <a:noFill/>
+          </a:ln>
+        </p:spPr>
+        <p:style>
+          <a:lnRef idx="1">
+            <a:schemeClr val="accent1"/>
+          </a:lnRef>
+          <a:fillRef idx="3">
+            <a:schemeClr val="accent1"/>
+          </a:fillRef>
+          <a:effectRef idx="2">
+            <a:schemeClr val="accent1"/>
+          </a:effectRef>
+          <a:fontRef idx="minor">
+            <a:schemeClr val="lt1"/>
+          </a:fontRef>
+        </p:style>
+        <p:txBody>
+          <a:bodyPr rtlCol="0" anchor="ctr"/>
+          <a:lstStyle/>
+          <a:p>
+            <a:pPr algn="ctr"/>
+          </a:p>
+        </p:txBody>
+      </p:sp>
+      <p:sp>
+        <p:nvSpPr>
+          <p:cNvPr id="3" name="TextBox 2"/>
           <p:cNvSpPr txBox="1"/>
           <p:nvPr/>
         </p:nvSpPr>
         <p:spPr>
           <a:xfrm>
-            <a:off x="914400" y="457200"/>
-            <a:ext cx="10058400" cy="1097280"/>
+            <a:off x="914400" y="137160"/>
+            <a:ext cx="10058400" cy="731520"/>
           </a:xfrm>
           <a:prstGeom prst="rect">
             <a:avLst/>
@@ -5196,27 +4664,27 @@
           <a:lstStyle/>
           <a:p>
             <a:pPr>
-              <a:defRPr sz="4000" b="1">
-                <a:solidFill>
-                  <a:srgbClr val="333333"/>
-                </a:solidFill>
-              </a:defRPr>
-            </a:pPr>
-            <a:r>
-              <a:t>왜 HSV인가?</a:t>
-            </a:r>
-          </a:p>
-        </p:txBody>
-      </p:sp>
-      <p:sp>
-        <p:nvSpPr>
-          <p:cNvPr id="3" name="TextBox 2"/>
+              <a:defRPr sz="3200" b="1">
+                <a:solidFill>
+                  <a:srgbClr val="FFFFFF"/>
+                </a:solidFill>
+              </a:defRPr>
+            </a:pPr>
+            <a:r>
+              <a:t>추가 요청: HuggingFace 전처리</a:t>
+            </a:r>
+          </a:p>
+        </p:txBody>
+      </p:sp>
+      <p:sp>
+        <p:nvSpPr>
+          <p:cNvPr id="4" name="TextBox 3"/>
           <p:cNvSpPr txBox="1"/>
           <p:nvPr/>
         </p:nvSpPr>
         <p:spPr>
           <a:xfrm>
-            <a:off x="1371600" y="1828800"/>
+            <a:off x="1371600" y="1371600"/>
             <a:ext cx="9144000" cy="4114800"/>
           </a:xfrm>
           <a:prstGeom prst="rect">
@@ -5232,19 +4700,112 @@
           <a:p/>
           <a:p>
             <a:pPr>
-              <a:defRPr sz="2000" b="0">
+              <a:defRPr sz="2000" b="1">
+                <a:solidFill>
+                  <a:srgbClr val="34495E"/>
+                </a:solidFill>
+              </a:defRPr>
+            </a:pPr>
+            <a:r>
+              <a:t>HuggingFace ethz/food101</a:t>
+            </a:r>
+          </a:p>
+          <a:p>
+            <a:pPr>
+              <a:defRPr sz="1600" b="0">
+                <a:solidFill>
+                  <a:srgbClr val="555555"/>
+                </a:solidFill>
+              </a:defRPr>
+            </a:pPr>
+            <a:r>
+              <a:t>  75,750장 / 101종 / 평균 502x476 px</a:t>
+            </a:r>
+          </a:p>
+          <a:p>
+            <a:pPr>
+              <a:defRPr sz="600" b="0">
                 <a:solidFill>
                   <a:srgbClr val="333333"/>
                 </a:solidFill>
               </a:defRPr>
             </a:pPr>
-            <a:r>
-              <a:t>RGB는 조명 변화에 민감. HSV는 Hue/Saturation/Value를 분리하여 조명 변화에 강함.</a:t>
-            </a:r>
-          </a:p>
-          <a:p>
-            <a:pPr>
-              <a:defRPr sz="800" b="0">
+          </a:p>
+          <a:p>
+            <a:pPr>
+              <a:defRPr sz="2200" b="1">
+                <a:solidFill>
+                  <a:srgbClr val="E74C3C"/>
+                </a:solidFill>
+              </a:defRPr>
+            </a:pPr>
+            <a:r>
+              <a:t>[기본 문제]</a:t>
+            </a:r>
+          </a:p>
+          <a:p>
+            <a:pPr>
+              <a:defRPr sz="1600" b="0">
+                <a:solidFill>
+                  <a:srgbClr val="555555"/>
+                </a:solidFill>
+              </a:defRPr>
+            </a:pPr>
+            <a:r>
+              <a:t>  1) 크기 조정      → cv2.resize() 224 X 224</a:t>
+            </a:r>
+          </a:p>
+          <a:p>
+            <a:pPr>
+              <a:defRPr sz="1600" b="0">
+                <a:solidFill>
+                  <a:srgbClr val="555555"/>
+                </a:solidFill>
+              </a:defRPr>
+            </a:pPr>
+            <a:r>
+              <a:t>  2) Grayscale      → cv2.cvtColor(..., GRAY)</a:t>
+            </a:r>
+          </a:p>
+          <a:p>
+            <a:pPr>
+              <a:defRPr sz="1600" b="0">
+                <a:solidFill>
+                  <a:srgbClr val="555555"/>
+                </a:solidFill>
+              </a:defRPr>
+            </a:pPr>
+            <a:r>
+              <a:t>  3) Normalize      → / 255.0  [0, 1]</a:t>
+            </a:r>
+          </a:p>
+          <a:p>
+            <a:pPr>
+              <a:defRPr sz="1600" b="0">
+                <a:solidFill>
+                  <a:srgbClr val="555555"/>
+                </a:solidFill>
+              </a:defRPr>
+            </a:pPr>
+            <a:r>
+              <a:t>  4) Blur 필터     → cv2.GaussianBlur(5x5)</a:t>
+            </a:r>
+          </a:p>
+          <a:p>
+            <a:pPr>
+              <a:defRPr sz="1600" b="0">
+                <a:solidFill>
+                  <a:srgbClr val="555555"/>
+                </a:solidFill>
+              </a:defRPr>
+            </a:pPr>
+            <a:r>
+              <a:t>  5) 데이터 증강   → 좌우반전, 15도회전, 밝기+30</a:t>
+            </a:r>
+          </a:p>
+          <a:p>
+            <a:pPr>
+              <a:defRPr sz="600" b="0">
                 <a:solidFill>
                   <a:srgbClr val="333333"/>
                 </a:solidFill>
@@ -5253,68 +4814,95 @@
           </a:p>
           <a:p>
             <a:pPr>
-              <a:defRPr sz="2000" b="1">
+              <a:defRPr sz="2200" b="1">
+                <a:solidFill>
+                  <a:srgbClr val="E74C3C"/>
+                </a:solidFill>
+              </a:defRPr>
+            </a:pPr>
+            <a:r>
+              <a:t>[심화 문제]  이상치 탐지</a:t>
+            </a:r>
+          </a:p>
+          <a:p>
+            <a:pPr>
+              <a:defRPr sz="1600" b="0">
+                <a:solidFill>
+                  <a:srgbClr val="555555"/>
+                </a:solidFill>
+              </a:defRPr>
+            </a:pPr>
+            <a:r>
+              <a:t>  - 너무 어두운 이미지: np.mean(gray) &lt; 30 → skip</a:t>
+            </a:r>
+          </a:p>
+          <a:p>
+            <a:pPr>
+              <a:defRPr sz="1600" b="0">
+                <a:solidFill>
+                  <a:srgbClr val="555555"/>
+                </a:solidFill>
+              </a:defRPr>
+            </a:pPr>
+            <a:r>
+              <a:t>  - 객체 작은 이미지: OTSU threshold → contour 면적 &lt; 10% → skip</a:t>
+            </a:r>
+          </a:p>
+          <a:p>
+            <a:pPr>
+              <a:defRPr sz="600" b="0">
                 <a:solidFill>
                   <a:srgbClr val="333333"/>
                 </a:solidFill>
               </a:defRPr>
             </a:pPr>
-            <a:r>
-              <a:t>빨간색은 HSV 0도 와 180도 경계에 걸려 있으므로 두 범위를 합쳐야 함.</a:t>
-            </a:r>
-          </a:p>
-          <a:p>
-            <a:pPr>
-              <a:defRPr sz="800" b="0">
-                <a:solidFill>
-                  <a:srgbClr val="333333"/>
-                </a:solidFill>
-              </a:defRPr>
-            </a:pPr>
-          </a:p>
-          <a:p>
-            <a:pPr>
-              <a:defRPr sz="1800" b="0">
-                <a:solidFill>
-                  <a:srgbClr val="C0392B"/>
-                </a:solidFill>
-              </a:defRPr>
-            </a:pPr>
-            <a:r>
-              <a:t>Lower Red 1: [0, 120, 70]  -&gt;  Upper Red 1: [10, 255, 255]</a:t>
-            </a:r>
-          </a:p>
-          <a:p>
-            <a:pPr>
-              <a:defRPr sz="1800" b="0">
-                <a:solidFill>
-                  <a:srgbClr val="C0392B"/>
-                </a:solidFill>
-              </a:defRPr>
-            </a:pPr>
-            <a:r>
-              <a:t>Lower Red 2: [170, 120, 70] -&gt; Upper Red 2: [180, 255, 255]</a:t>
-            </a:r>
-          </a:p>
-          <a:p>
-            <a:pPr>
-              <a:defRPr sz="800" b="0">
-                <a:solidFill>
-                  <a:srgbClr val="333333"/>
-                </a:solidFill>
-              </a:defRPr>
-            </a:pPr>
-          </a:p>
-          <a:p>
-            <a:pPr>
-              <a:defRPr sz="1800" b="0">
-                <a:solidFill>
-                  <a:srgbClr val="E74C3C"/>
-                </a:solidFill>
-              </a:defRPr>
-            </a:pPr>
-            <a:r>
-              <a:t>mask1 + mask2 대신 cv2.bitwise_or() 사용 (uint8 overflow 방지)</a:t>
+          </a:p>
+          <a:p>
+            <a:pPr>
+              <a:defRPr sz="1800" b="1">
+                <a:solidFill>
+                  <a:srgbClr val="27AE60"/>
+                </a:solidFill>
+              </a:defRPr>
+            </a:pPr>
+            <a:r>
+              <a:t>의존성: OpenCV + NumPy + datasets + pandas 만 사용</a:t>
+            </a:r>
+          </a:p>
+        </p:txBody>
+      </p:sp>
+      <p:sp>
+        <p:nvSpPr>
+          <p:cNvPr id="5" name="TextBox 4"/>
+          <p:cNvSpPr txBox="1"/>
+          <p:nvPr/>
+        </p:nvSpPr>
+        <p:spPr>
+          <a:xfrm>
+            <a:off x="1371600" y="5943600"/>
+            <a:ext cx="9144000" cy="457200"/>
+          </a:xfrm>
+          <a:prstGeom prst="rect">
+            <a:avLst/>
+          </a:prstGeom>
+          <a:noFill/>
+        </p:spPr>
+        <p:txBody>
+          <a:bodyPr wrap="square">
+            <a:spAutoFit/>
+          </a:bodyPr>
+          <a:lstStyle/>
+          <a:p/>
+          <a:p>
+            <a:pPr>
+              <a:defRPr sz="1400" b="0">
+                <a:solidFill>
+                  <a:srgbClr val="555555"/>
+                </a:solidFill>
+              </a:defRPr>
+            </a:pPr>
+            <a:r>
+              <a:t>image_preprocessing.py 전체 파이프라인 → 5개 샘플 × 4종 증강 = preprocessed_samples/ 20장</a:t>
             </a:r>
           </a:p>
         </p:txBody>
@@ -5339,14 +4927,57 @@
       <p:grpSpPr/>
       <p:sp>
         <p:nvSpPr>
-          <p:cNvPr id="2" name="TextBox 1"/>
+          <p:cNvPr id="2" name="Rectangle 1"/>
+          <p:cNvSpPr/>
+          <p:nvPr/>
+        </p:nvSpPr>
+        <p:spPr>
+          <a:xfrm>
+            <a:off x="0" y="0"/>
+            <a:ext cx="12191695" cy="1005840"/>
+          </a:xfrm>
+          <a:prstGeom prst="rect">
+            <a:avLst/>
+          </a:prstGeom>
+          <a:solidFill>
+            <a:srgbClr val="34495E"/>
+          </a:solidFill>
+          <a:ln>
+            <a:noFill/>
+          </a:ln>
+        </p:spPr>
+        <p:style>
+          <a:lnRef idx="1">
+            <a:schemeClr val="accent1"/>
+          </a:lnRef>
+          <a:fillRef idx="3">
+            <a:schemeClr val="accent1"/>
+          </a:fillRef>
+          <a:effectRef idx="2">
+            <a:schemeClr val="accent1"/>
+          </a:effectRef>
+          <a:fontRef idx="minor">
+            <a:schemeClr val="lt1"/>
+          </a:fontRef>
+        </p:style>
+        <p:txBody>
+          <a:bodyPr rtlCol="0" anchor="ctr"/>
+          <a:lstStyle/>
+          <a:p>
+            <a:pPr algn="ctr"/>
+          </a:p>
+        </p:txBody>
+      </p:sp>
+      <p:sp>
+        <p:nvSpPr>
+          <p:cNvPr id="3" name="TextBox 2"/>
           <p:cNvSpPr txBox="1"/>
           <p:nvPr/>
         </p:nvSpPr>
         <p:spPr>
           <a:xfrm>
-            <a:off x="914400" y="457200"/>
-            <a:ext cx="10058400" cy="1097280"/>
+            <a:off x="914400" y="137160"/>
+            <a:ext cx="10058400" cy="731520"/>
           </a:xfrm>
           <a:prstGeom prst="rect">
             <a:avLst/>
@@ -5354,34 +4985,34 @@
           <a:noFill/>
         </p:spPr>
         <p:txBody>
-          <a:bodyPr wrap="square">
+          <a:bodyPr wrap="none">
             <a:spAutoFit/>
           </a:bodyPr>
           <a:lstStyle/>
           <a:p>
             <a:pPr>
-              <a:defRPr sz="4000" b="1">
-                <a:solidFill>
-                  <a:srgbClr val="333333"/>
-                </a:solidFill>
-              </a:defRPr>
-            </a:pPr>
-            <a:r>
-              <a:t>코드 (red.py)</a:t>
-            </a:r>
-          </a:p>
-        </p:txBody>
-      </p:sp>
-      <p:sp>
-        <p:nvSpPr>
-          <p:cNvPr id="3" name="TextBox 2"/>
+              <a:defRPr sz="3200" b="1">
+                <a:solidFill>
+                  <a:srgbClr val="FFFFFF"/>
+                </a:solidFill>
+              </a:defRPr>
+            </a:pPr>
+            <a:r>
+              <a:t>Before / After</a:t>
+            </a:r>
+          </a:p>
+        </p:txBody>
+      </p:sp>
+      <p:sp>
+        <p:nvSpPr>
+          <p:cNvPr id="4" name="TextBox 3"/>
           <p:cNvSpPr txBox="1"/>
           <p:nvPr/>
         </p:nvSpPr>
         <p:spPr>
           <a:xfrm>
-            <a:off x="1371600" y="1828800"/>
-            <a:ext cx="9144000" cy="4114800"/>
+            <a:off x="1828800" y="1371600"/>
+            <a:ext cx="2011680" cy="365760"/>
           </a:xfrm>
           <a:prstGeom prst="rect">
             <a:avLst/>
@@ -5395,165 +5026,255 @@
           <a:lstStyle/>
           <a:p/>
           <a:p>
-            <a:pPr>
-              <a:defRPr sz="1700" b="0">
-                <a:solidFill>
-                  <a:srgbClr val="444444"/>
-                </a:solidFill>
-              </a:defRPr>
-            </a:pPr>
-            <a:r>
-              <a:t>import cv2, numpy as np</a:t>
-            </a:r>
-          </a:p>
-          <a:p>
-            <a:pPr>
-              <a:defRPr sz="1700" b="0">
-                <a:solidFill>
-                  <a:srgbClr val="444444"/>
-                </a:solidFill>
-              </a:defRPr>
-            </a:pPr>
-            <a:r>
-              <a:t>image = cv2.imread('sample.jpg')</a:t>
-            </a:r>
-          </a:p>
-          <a:p>
-            <a:pPr>
-              <a:defRPr sz="1700" b="0">
-                <a:solidFill>
-                  <a:srgbClr val="444444"/>
-                </a:solidFill>
-              </a:defRPr>
-            </a:pPr>
-            <a:r>
-              <a:t>hsv = cv2.cvtColor(image, cv2.COLOR_BGR2HSV)</a:t>
-            </a:r>
-          </a:p>
-          <a:p>
-            <a:pPr>
-              <a:defRPr sz="1700" b="0">
-                <a:solidFill>
-                  <a:srgbClr val="444444"/>
-                </a:solidFill>
-              </a:defRPr>
-            </a:pPr>
-          </a:p>
-          <a:p>
-            <a:pPr>
-              <a:defRPr sz="1700" b="0">
-                <a:solidFill>
-                  <a:srgbClr val="444444"/>
-                </a:solidFill>
-              </a:defRPr>
-            </a:pPr>
-            <a:r>
-              <a:t>lower_red1 = np.array([0, 120, 70])</a:t>
-            </a:r>
-          </a:p>
-          <a:p>
-            <a:pPr>
-              <a:defRPr sz="1700" b="0">
-                <a:solidFill>
-                  <a:srgbClr val="444444"/>
-                </a:solidFill>
-              </a:defRPr>
-            </a:pPr>
-            <a:r>
-              <a:t>upper_red1 = np.array([10, 255, 255])</a:t>
-            </a:r>
-          </a:p>
-          <a:p>
-            <a:pPr>
-              <a:defRPr sz="1700" b="0">
-                <a:solidFill>
-                  <a:srgbClr val="444444"/>
-                </a:solidFill>
-              </a:defRPr>
-            </a:pPr>
-            <a:r>
-              <a:t>lower_red2 = np.array([170, 120, 70])</a:t>
-            </a:r>
-          </a:p>
-          <a:p>
-            <a:pPr>
-              <a:defRPr sz="1700" b="0">
-                <a:solidFill>
-                  <a:srgbClr val="444444"/>
-                </a:solidFill>
-              </a:defRPr>
-            </a:pPr>
-            <a:r>
-              <a:t>upper_red2 = np.array([180, 255, 255])</a:t>
-            </a:r>
-          </a:p>
-          <a:p>
-            <a:pPr>
-              <a:defRPr sz="1700" b="0">
-                <a:solidFill>
-                  <a:srgbClr val="444444"/>
-                </a:solidFill>
-              </a:defRPr>
-            </a:pPr>
-          </a:p>
-          <a:p>
-            <a:pPr>
-              <a:defRPr sz="1700" b="0">
-                <a:solidFill>
-                  <a:srgbClr val="444444"/>
-                </a:solidFill>
-              </a:defRPr>
-            </a:pPr>
-            <a:r>
-              <a:t>mask1 = cv2.inRange(hsv, lower_red1, upper_red1)</a:t>
-            </a:r>
-          </a:p>
-          <a:p>
-            <a:pPr>
-              <a:defRPr sz="1700" b="0">
-                <a:solidFill>
-                  <a:srgbClr val="444444"/>
-                </a:solidFill>
-              </a:defRPr>
-            </a:pPr>
-            <a:r>
-              <a:t>mask2 = cv2.inRange(hsv, lower_red2, upper_red2)</a:t>
-            </a:r>
-          </a:p>
-          <a:p>
-            <a:pPr>
-              <a:defRPr sz="1700" b="0">
-                <a:solidFill>
-                  <a:srgbClr val="444444"/>
-                </a:solidFill>
-              </a:defRPr>
-            </a:pPr>
-            <a:r>
-              <a:t>mask  = cv2.bitwise_or(mask1, mask2)</a:t>
-            </a:r>
-          </a:p>
-          <a:p>
-            <a:pPr>
-              <a:defRPr sz="1700" b="0">
-                <a:solidFill>
-                  <a:srgbClr val="444444"/>
-                </a:solidFill>
-              </a:defRPr>
-            </a:pPr>
-            <a:r>
-              <a:t>result = cv2.bitwise_and(image, image, mask=mask)</a:t>
-            </a:r>
-          </a:p>
-          <a:p>
-            <a:pPr>
-              <a:defRPr sz="1700" b="0">
-                <a:solidFill>
-                  <a:srgbClr val="444444"/>
-                </a:solidFill>
-              </a:defRPr>
-            </a:pPr>
-            <a:r>
-              <a:t>cv2.imwrite('red_filtered.jpg', result)</a:t>
+            <a:pPr algn="ctr">
+              <a:defRPr sz="1400" b="0">
+                <a:solidFill>
+                  <a:srgbClr val="555555"/>
+                </a:solidFill>
+              </a:defRPr>
+            </a:pPr>
+            <a:r>
+              <a:t>Original</a:t>
+            </a:r>
+          </a:p>
+        </p:txBody>
+      </p:sp>
+      <p:sp>
+        <p:nvSpPr>
+          <p:cNvPr id="5" name="TextBox 4"/>
+          <p:cNvSpPr txBox="1"/>
+          <p:nvPr/>
+        </p:nvSpPr>
+        <p:spPr>
+          <a:xfrm>
+            <a:off x="6858000" y="1371600"/>
+            <a:ext cx="2011680" cy="365760"/>
+          </a:xfrm>
+          <a:prstGeom prst="rect">
+            <a:avLst/>
+          </a:prstGeom>
+          <a:noFill/>
+        </p:spPr>
+        <p:txBody>
+          <a:bodyPr wrap="square">
+            <a:spAutoFit/>
+          </a:bodyPr>
+          <a:lstStyle/>
+          <a:p/>
+          <a:p>
+            <a:pPr algn="ctr">
+              <a:defRPr sz="1400" b="0">
+                <a:solidFill>
+                  <a:srgbClr val="555555"/>
+                </a:solidFill>
+              </a:defRPr>
+            </a:pPr>
+            <a:r>
+              <a:t>Red Filtered</a:t>
+            </a:r>
+          </a:p>
+        </p:txBody>
+      </p:sp>
+      <p:pic>
+        <p:nvPicPr>
+          <p:cNvPr id="6" name="Picture 5" descr="sample.jpg"/>
+          <p:cNvPicPr>
+            <a:picLocks noChangeAspect="1"/>
+          </p:cNvPicPr>
+          <p:nvPr/>
+        </p:nvPicPr>
+        <p:blipFill>
+          <a:blip r:embed="rId2"/>
+          <a:stretch>
+            <a:fillRect/>
+          </a:stretch>
+        </p:blipFill>
+        <p:spPr>
+          <a:xfrm>
+            <a:off x="1828800" y="1645920"/>
+            <a:ext cx="2011680" cy="1734039"/>
+          </a:xfrm>
+          <a:prstGeom prst="rect">
+            <a:avLst/>
+          </a:prstGeom>
+        </p:spPr>
+      </p:pic>
+      <p:pic>
+        <p:nvPicPr>
+          <p:cNvPr id="7" name="Picture 6" descr="red_filtered.jpg"/>
+          <p:cNvPicPr>
+            <a:picLocks noChangeAspect="1"/>
+          </p:cNvPicPr>
+          <p:nvPr/>
+        </p:nvPicPr>
+        <p:blipFill>
+          <a:blip r:embed="rId3"/>
+          <a:stretch>
+            <a:fillRect/>
+          </a:stretch>
+        </p:blipFill>
+        <p:spPr>
+          <a:xfrm>
+            <a:off x="6858000" y="1645920"/>
+            <a:ext cx="2011680" cy="1734039"/>
+          </a:xfrm>
+          <a:prstGeom prst="rect">
+            <a:avLst/>
+          </a:prstGeom>
+        </p:spPr>
+      </p:pic>
+      <p:sp>
+        <p:nvSpPr>
+          <p:cNvPr id="8" name="TextBox 7"/>
+          <p:cNvSpPr txBox="1"/>
+          <p:nvPr/>
+        </p:nvSpPr>
+        <p:spPr>
+          <a:xfrm>
+            <a:off x="1828800" y="3657600"/>
+            <a:ext cx="2011680" cy="365760"/>
+          </a:xfrm>
+          <a:prstGeom prst="rect">
+            <a:avLst/>
+          </a:prstGeom>
+          <a:noFill/>
+        </p:spPr>
+        <p:txBody>
+          <a:bodyPr wrap="square">
+            <a:spAutoFit/>
+          </a:bodyPr>
+          <a:lstStyle/>
+          <a:p/>
+          <a:p>
+            <a:pPr algn="ctr">
+              <a:defRPr sz="1400" b="0">
+                <a:solidFill>
+                  <a:srgbClr val="555555"/>
+                </a:solidFill>
+              </a:defRPr>
+            </a:pPr>
+            <a:r>
+              <a:t>Raw Food101</a:t>
+            </a:r>
+          </a:p>
+        </p:txBody>
+      </p:sp>
+      <p:sp>
+        <p:nvSpPr>
+          <p:cNvPr id="9" name="TextBox 8"/>
+          <p:cNvSpPr txBox="1"/>
+          <p:nvPr/>
+        </p:nvSpPr>
+        <p:spPr>
+          <a:xfrm>
+            <a:off x="6858000" y="3657600"/>
+            <a:ext cx="2011680" cy="365760"/>
+          </a:xfrm>
+          <a:prstGeom prst="rect">
+            <a:avLst/>
+          </a:prstGeom>
+          <a:noFill/>
+        </p:spPr>
+        <p:txBody>
+          <a:bodyPr wrap="square">
+            <a:spAutoFit/>
+          </a:bodyPr>
+          <a:lstStyle/>
+          <a:p/>
+          <a:p>
+            <a:pPr algn="ctr">
+              <a:defRPr sz="1400" b="0">
+                <a:solidFill>
+                  <a:srgbClr val="555555"/>
+                </a:solidFill>
+              </a:defRPr>
+            </a:pPr>
+            <a:r>
+              <a:t>Preprocessed</a:t>
+            </a:r>
+          </a:p>
+        </p:txBody>
+      </p:sp>
+      <p:pic>
+        <p:nvPicPr>
+          <p:cNvPr id="10" name="Picture 9" descr="01_beignets_raw.jpg"/>
+          <p:cNvPicPr>
+            <a:picLocks noChangeAspect="1"/>
+          </p:cNvPicPr>
+          <p:nvPr/>
+        </p:nvPicPr>
+        <p:blipFill>
+          <a:blip r:embed="rId4"/>
+          <a:stretch>
+            <a:fillRect/>
+          </a:stretch>
+        </p:blipFill>
+        <p:spPr>
+          <a:xfrm>
+            <a:off x="1828800" y="3931920"/>
+            <a:ext cx="2011680" cy="2682240"/>
+          </a:xfrm>
+          <a:prstGeom prst="rect">
+            <a:avLst/>
+          </a:prstGeom>
+        </p:spPr>
+      </p:pic>
+      <p:pic>
+        <p:nvPicPr>
+          <p:cNvPr id="11" name="Picture 10" descr="01_beignets_preprocessed.jpg"/>
+          <p:cNvPicPr>
+            <a:picLocks noChangeAspect="1"/>
+          </p:cNvPicPr>
+          <p:nvPr/>
+        </p:nvPicPr>
+        <p:blipFill>
+          <a:blip r:embed="rId5"/>
+          <a:stretch>
+            <a:fillRect/>
+          </a:stretch>
+        </p:blipFill>
+        <p:spPr>
+          <a:xfrm>
+            <a:off x="6858000" y="3931920"/>
+            <a:ext cx="2011680" cy="2011680"/>
+          </a:xfrm>
+          <a:prstGeom prst="rect">
+            <a:avLst/>
+          </a:prstGeom>
+        </p:spPr>
+      </p:pic>
+      <p:sp>
+        <p:nvSpPr>
+          <p:cNvPr id="12" name="TextBox 11"/>
+          <p:cNvSpPr txBox="1"/>
+          <p:nvPr/>
+        </p:nvSpPr>
+        <p:spPr>
+          <a:xfrm>
+            <a:off x="1371600" y="5943600"/>
+            <a:ext cx="9144000" cy="457200"/>
+          </a:xfrm>
+          <a:prstGeom prst="rect">
+            <a:avLst/>
+          </a:prstGeom>
+          <a:noFill/>
+        </p:spPr>
+        <p:txBody>
+          <a:bodyPr wrap="square">
+            <a:spAutoFit/>
+          </a:bodyPr>
+          <a:lstStyle/>
+          <a:p/>
+          <a:p>
+            <a:pPr>
+              <a:defRPr sz="1400" b="0">
+                <a:solidFill>
+                  <a:srgbClr val="555555"/>
+                </a:solidFill>
+              </a:defRPr>
+            </a:pPr>
+            <a:r>
+              <a:t>left: original images | right: after processing</a:t>
             </a:r>
           </a:p>
         </p:txBody>
@@ -5578,14 +5299,57 @@
       <p:grpSpPr/>
       <p:sp>
         <p:nvSpPr>
-          <p:cNvPr id="2" name="TextBox 1"/>
+          <p:cNvPr id="2" name="Rectangle 1"/>
+          <p:cNvSpPr/>
+          <p:nvPr/>
+        </p:nvSpPr>
+        <p:spPr>
+          <a:xfrm>
+            <a:off x="0" y="0"/>
+            <a:ext cx="12191695" cy="1005840"/>
+          </a:xfrm>
+          <a:prstGeom prst="rect">
+            <a:avLst/>
+          </a:prstGeom>
+          <a:solidFill>
+            <a:srgbClr val="34495E"/>
+          </a:solidFill>
+          <a:ln>
+            <a:noFill/>
+          </a:ln>
+        </p:spPr>
+        <p:style>
+          <a:lnRef idx="1">
+            <a:schemeClr val="accent1"/>
+          </a:lnRef>
+          <a:fillRef idx="3">
+            <a:schemeClr val="accent1"/>
+          </a:fillRef>
+          <a:effectRef idx="2">
+            <a:schemeClr val="accent1"/>
+          </a:effectRef>
+          <a:fontRef idx="minor">
+            <a:schemeClr val="lt1"/>
+          </a:fontRef>
+        </p:style>
+        <p:txBody>
+          <a:bodyPr rtlCol="0" anchor="ctr"/>
+          <a:lstStyle/>
+          <a:p>
+            <a:pPr algn="ctr"/>
+          </a:p>
+        </p:txBody>
+      </p:sp>
+      <p:sp>
+        <p:nvSpPr>
+          <p:cNvPr id="3" name="TextBox 2"/>
           <p:cNvSpPr txBox="1"/>
           <p:nvPr/>
         </p:nvSpPr>
         <p:spPr>
           <a:xfrm>
-            <a:off x="914400" y="457200"/>
-            <a:ext cx="10058400" cy="1097280"/>
+            <a:off x="914400" y="137160"/>
+            <a:ext cx="10058400" cy="731520"/>
           </a:xfrm>
           <a:prstGeom prst="rect">
             <a:avLst/>
@@ -5599,28 +5363,28 @@
           <a:lstStyle/>
           <a:p>
             <a:pPr>
-              <a:defRPr sz="4000" b="1">
-                <a:solidFill>
-                  <a:srgbClr val="333333"/>
-                </a:solidFill>
-              </a:defRPr>
-            </a:pPr>
-            <a:r>
-              <a:t>결과</a:t>
-            </a:r>
-          </a:p>
-        </p:txBody>
-      </p:sp>
-      <p:sp>
-        <p:nvSpPr>
-          <p:cNvPr id="3" name="TextBox 2"/>
+              <a:defRPr sz="3200" b="1">
+                <a:solidFill>
+                  <a:srgbClr val="FFFFFF"/>
+                </a:solidFill>
+              </a:defRPr>
+            </a:pPr>
+            <a:r>
+              <a:t>GitHub Repository</a:t>
+            </a:r>
+          </a:p>
+        </p:txBody>
+      </p:sp>
+      <p:sp>
+        <p:nvSpPr>
+          <p:cNvPr id="4" name="TextBox 3"/>
           <p:cNvSpPr txBox="1"/>
           <p:nvPr/>
         </p:nvSpPr>
         <p:spPr>
           <a:xfrm>
-            <a:off x="1828800" y="1828800"/>
-            <a:ext cx="3657600" cy="457200"/>
+            <a:off x="1371600" y="1371600"/>
+            <a:ext cx="9144000" cy="4114800"/>
           </a:xfrm>
           <a:prstGeom prst="rect">
             <a:avLst/>
@@ -5634,58 +5398,46 @@
           <a:lstStyle/>
           <a:p/>
           <a:p>
-            <a:pPr algn="ctr">
-              <a:defRPr sz="1800" b="1">
-                <a:solidFill>
-                  <a:srgbClr val="333333"/>
-                </a:solidFill>
-              </a:defRPr>
-            </a:pPr>
-            <a:r>
-              <a:t>원본</a:t>
-            </a:r>
-          </a:p>
-        </p:txBody>
-      </p:sp>
-      <p:sp>
-        <p:nvSpPr>
-          <p:cNvPr id="4" name="TextBox 3"/>
-          <p:cNvSpPr txBox="1"/>
-          <p:nvPr/>
-        </p:nvSpPr>
-        <p:spPr>
-          <a:xfrm>
-            <a:off x="6858000" y="1828800"/>
-            <a:ext cx="3657600" cy="457200"/>
-          </a:xfrm>
-          <a:prstGeom prst="rect">
-            <a:avLst/>
-          </a:prstGeom>
-          <a:noFill/>
-        </p:spPr>
-        <p:txBody>
-          <a:bodyPr wrap="square">
-            <a:spAutoFit/>
-          </a:bodyPr>
-          <a:lstStyle/>
-          <a:p/>
-          <a:p>
-            <a:pPr algn="ctr">
-              <a:defRPr sz="1800" b="1">
-                <a:solidFill>
-                  <a:srgbClr val="333333"/>
-                </a:solidFill>
-              </a:defRPr>
-            </a:pPr>
-            <a:r>
-              <a:t>검출 결과</a:t>
+            <a:pPr>
+              <a:defRPr sz="2000" b="1">
+                <a:solidFill>
+                  <a:srgbClr val="34495E"/>
+                </a:solidFill>
+              </a:defRPr>
+            </a:pPr>
+            <a:r>
+              <a:t>저장소: jsm0308/Bootcamp-CV</a:t>
+            </a:r>
+          </a:p>
+          <a:p>
+            <a:pPr>
+              <a:defRPr sz="1600" b="0">
+                <a:solidFill>
+                  <a:srgbClr val="555555"/>
+                </a:solidFill>
+              </a:defRPr>
+            </a:pPr>
+            <a:r>
+              <a:t>git/  → 핵심 과제: red.py (빨간색 검출)</a:t>
+            </a:r>
+          </a:p>
+          <a:p>
+            <a:pPr>
+              <a:defRPr sz="1600" b="0">
+                <a:solidFill>
+                  <a:srgbClr val="555555"/>
+                </a:solidFill>
+              </a:defRPr>
+            </a:pPr>
+            <a:r>
+              <a:t>huggingface/ → 추가 과제: dataset.py, image_preprocessing.py</a:t>
             </a:r>
           </a:p>
         </p:txBody>
       </p:sp>
       <p:pic>
         <p:nvPicPr>
-          <p:cNvPr id="5" name="Picture 4" descr="sample.jpg"/>
+          <p:cNvPr id="5" name="Picture 4" descr="jsm0308-Bootcamp-CV.png"/>
           <p:cNvPicPr>
             <a:picLocks noChangeAspect="1"/>
           </p:cNvPicPr>
@@ -5699,74 +5451,14 @@
         </p:blipFill>
         <p:spPr>
           <a:xfrm>
-            <a:off x="1828800" y="2286000"/>
-            <a:ext cx="3657600" cy="3152798"/>
+            <a:off x="6858000" y="1645920"/>
+            <a:ext cx="4572000" cy="2114550"/>
           </a:xfrm>
           <a:prstGeom prst="rect">
             <a:avLst/>
           </a:prstGeom>
         </p:spPr>
       </p:pic>
-      <p:pic>
-        <p:nvPicPr>
-          <p:cNvPr id="6" name="Picture 5" descr="red_filtered.jpg"/>
-          <p:cNvPicPr>
-            <a:picLocks noChangeAspect="1"/>
-          </p:cNvPicPr>
-          <p:nvPr/>
-        </p:nvPicPr>
-        <p:blipFill>
-          <a:blip r:embed="rId3"/>
-          <a:stretch>
-            <a:fillRect/>
-          </a:stretch>
-        </p:blipFill>
-        <p:spPr>
-          <a:xfrm>
-            <a:off x="6858000" y="2286000"/>
-            <a:ext cx="3657600" cy="3152798"/>
-          </a:xfrm>
-          <a:prstGeom prst="rect">
-            <a:avLst/>
-          </a:prstGeom>
-        </p:spPr>
-      </p:pic>
-      <p:sp>
-        <p:nvSpPr>
-          <p:cNvPr id="7" name="TextBox 6"/>
-          <p:cNvSpPr txBox="1"/>
-          <p:nvPr/>
-        </p:nvSpPr>
-        <p:spPr>
-          <a:xfrm>
-            <a:off x="1371600" y="5486400"/>
-            <a:ext cx="9144000" cy="457200"/>
-          </a:xfrm>
-          <a:prstGeom prst="rect">
-            <a:avLst/>
-          </a:prstGeom>
-          <a:noFill/>
-        </p:spPr>
-        <p:txBody>
-          <a:bodyPr wrap="square">
-            <a:spAutoFit/>
-          </a:bodyPr>
-          <a:lstStyle/>
-          <a:p/>
-          <a:p>
-            <a:pPr>
-              <a:defRPr sz="1800" b="0">
-                <a:solidFill>
-                  <a:srgbClr val="555555"/>
-                </a:solidFill>
-              </a:defRPr>
-            </a:pPr>
-            <a:r>
-              <a:t>빨간색만 추출. 초록색/파란색은 마스킹되어 검은색으로 표시.</a:t>
-            </a:r>
-          </a:p>
-        </p:txBody>
-      </p:sp>
     </p:spTree>
   </p:cSld>
   <p:clrMapOvr>
@@ -5781,7 +5473,7 @@
     <p:bg>
       <p:bgPr>
         <a:solidFill>
-          <a:srgbClr val="34495E"/>
+          <a:srgbClr val="2C3E50"/>
         </a:solidFill>
         <a:effectLst/>
       </p:bgPr>
@@ -5801,8 +5493,8 @@
         </p:nvSpPr>
         <p:spPr>
           <a:xfrm>
-            <a:off x="914400" y="2286000"/>
-            <a:ext cx="10058400" cy="1828800"/>
+            <a:off x="1097280" y="548640"/>
+            <a:ext cx="4572000" cy="731520"/>
           </a:xfrm>
           <a:prstGeom prst="rect">
             <a:avLst/>
@@ -5817,26 +5509,410 @@
           <a:p/>
           <a:p>
             <a:pPr>
-              <a:defRPr sz="3800" b="1">
+              <a:defRPr sz="3000" b="1">
                 <a:solidFill>
                   <a:srgbClr val="FFFFFF"/>
                 </a:solidFill>
               </a:defRPr>
             </a:pPr>
             <a:r>
-              <a:t>Part 3. HuggingFace 데이터셋</a:t>
-            </a:r>
-          </a:p>
-          <a:p>
-            <a:pPr>
-              <a:defRPr sz="2200" b="0">
+              <a:t>Checklist</a:t>
+            </a:r>
+          </a:p>
+        </p:txBody>
+      </p:sp>
+      <p:sp>
+        <p:nvSpPr>
+          <p:cNvPr id="3" name="TextBox 2"/>
+          <p:cNvSpPr txBox="1"/>
+          <p:nvPr/>
+        </p:nvSpPr>
+        <p:spPr>
+          <a:xfrm>
+            <a:off x="1097280" y="1371600"/>
+            <a:ext cx="4572000" cy="4572000"/>
+          </a:xfrm>
+          <a:prstGeom prst="rect">
+            <a:avLst/>
+          </a:prstGeom>
+          <a:noFill/>
+        </p:spPr>
+        <p:txBody>
+          <a:bodyPr wrap="square">
+            <a:spAutoFit/>
+          </a:bodyPr>
+          <a:lstStyle/>
+          <a:p/>
+          <a:p>
+            <a:pPr>
+              <a:defRPr sz="1600" b="1">
                 <a:solidFill>
                   <a:srgbClr val="BBBBBB"/>
                 </a:solidFill>
               </a:defRPr>
             </a:pPr>
             <a:r>
-              <a:t>Food101 로드 · pandas EDA</a:t>
+              <a:t>    Status  Item</a:t>
+            </a:r>
+          </a:p>
+          <a:p>
+            <a:pPr>
+              <a:defRPr sz="1600" b="0">
+                <a:solidFill>
+                  <a:srgbClr val="27AE60"/>
+                </a:solidFill>
+              </a:defRPr>
+            </a:pPr>
+            <a:r>
+              <a:t>    [O]    Git 저장소 구성</a:t>
+            </a:r>
+          </a:p>
+          <a:p>
+            <a:pPr>
+              <a:defRPr sz="1600" b="0">
+                <a:solidFill>
+                  <a:srgbClr val="27AE60"/>
+                </a:solidFill>
+              </a:defRPr>
+            </a:pPr>
+            <a:r>
+              <a:t>    [O]    Branch / PR / Merge</a:t>
+            </a:r>
+          </a:p>
+          <a:p>
+            <a:pPr>
+              <a:defRPr sz="1600" b="0">
+                <a:solidFill>
+                  <a:srgbClr val="27AE60"/>
+                </a:solidFill>
+              </a:defRPr>
+            </a:pPr>
+            <a:r>
+              <a:t>    [O]    red.py 빨간색 검출</a:t>
+            </a:r>
+          </a:p>
+          <a:p>
+            <a:pPr>
+              <a:defRPr sz="1600" b="0">
+                <a:solidFill>
+                  <a:srgbClr val="27AE60"/>
+                </a:solidFill>
+              </a:defRPr>
+            </a:pPr>
+            <a:r>
+              <a:t>    [O]    dataset.py Food101 + pandas</a:t>
+            </a:r>
+          </a:p>
+          <a:p>
+            <a:pPr>
+              <a:defRPr sz="1600" b="0">
+                <a:solidFill>
+                  <a:srgbClr val="27AE60"/>
+                </a:solidFill>
+              </a:defRPr>
+            </a:pPr>
+            <a:r>
+              <a:t>    [O]    image_preprocessing.py</a:t>
+            </a:r>
+          </a:p>
+          <a:p>
+            <a:pPr>
+              <a:defRPr sz="1600" b="0">
+                <a:solidFill>
+                  <a:srgbClr val="27AE60"/>
+                </a:solidFill>
+              </a:defRPr>
+            </a:pPr>
+            <a:r>
+              <a:t>    [O]    Resize 224x224</a:t>
+            </a:r>
+          </a:p>
+          <a:p>
+            <a:pPr>
+              <a:defRPr sz="1600" b="0">
+                <a:solidFill>
+                  <a:srgbClr val="27AE60"/>
+                </a:solidFill>
+              </a:defRPr>
+            </a:pPr>
+            <a:r>
+              <a:t>    [O]    Grayscale + Normalize</a:t>
+            </a:r>
+          </a:p>
+          <a:p>
+            <a:pPr>
+              <a:defRPr sz="1600" b="0">
+                <a:solidFill>
+                  <a:srgbClr val="27AE60"/>
+                </a:solidFill>
+              </a:defRPr>
+            </a:pPr>
+            <a:r>
+              <a:t>    [O]    GaussianBlur 노이즈 제거</a:t>
+            </a:r>
+          </a:p>
+          <a:p>
+            <a:pPr>
+              <a:defRPr sz="1600" b="0">
+                <a:solidFill>
+                  <a:srgbClr val="27AE60"/>
+                </a:solidFill>
+              </a:defRPr>
+            </a:pPr>
+            <a:r>
+              <a:t>    [O]    증강 3종 (flip, rotate, bright)</a:t>
+            </a:r>
+          </a:p>
+          <a:p>
+            <a:pPr>
+              <a:defRPr sz="1600" b="0">
+                <a:solidFill>
+                  <a:srgbClr val="27AE60"/>
+                </a:solidFill>
+              </a:defRPr>
+            </a:pPr>
+            <a:r>
+              <a:t>    [O]    이상치 탐지 2종</a:t>
+            </a:r>
+          </a:p>
+          <a:p>
+            <a:pPr>
+              <a:defRPr sz="1600" b="0">
+                <a:solidFill>
+                  <a:srgbClr val="27AE60"/>
+                </a:solidFill>
+              </a:defRPr>
+            </a:pPr>
+            <a:r>
+              <a:t>    [O]    전처리 결과물 20장</a:t>
+            </a:r>
+          </a:p>
+          <a:p>
+            <a:pPr>
+              <a:defRPr sz="1600" b="0">
+                <a:solidFill>
+                  <a:srgbClr val="27AE60"/>
+                </a:solidFill>
+              </a:defRPr>
+            </a:pPr>
+            <a:r>
+              <a:t>    [O]    PPT 보고서</a:t>
+            </a:r>
+          </a:p>
+        </p:txBody>
+      </p:sp>
+      <p:sp>
+        <p:nvSpPr>
+          <p:cNvPr id="4" name="TextBox 3"/>
+          <p:cNvSpPr txBox="1"/>
+          <p:nvPr/>
+        </p:nvSpPr>
+        <p:spPr>
+          <a:xfrm>
+            <a:off x="6400800" y="548640"/>
+            <a:ext cx="4572000" cy="731520"/>
+          </a:xfrm>
+          <a:prstGeom prst="rect">
+            <a:avLst/>
+          </a:prstGeom>
+          <a:noFill/>
+        </p:spPr>
+        <p:txBody>
+          <a:bodyPr wrap="square">
+            <a:spAutoFit/>
+          </a:bodyPr>
+          <a:lstStyle/>
+          <a:p/>
+          <a:p>
+            <a:pPr>
+              <a:defRPr sz="3000" b="1">
+                <a:solidFill>
+                  <a:srgbClr val="FFFFFF"/>
+                </a:solidFill>
+              </a:defRPr>
+            </a:pPr>
+            <a:r>
+              <a:t>Lessons Learned</a:t>
+            </a:r>
+          </a:p>
+        </p:txBody>
+      </p:sp>
+      <p:sp>
+        <p:nvSpPr>
+          <p:cNvPr id="5" name="TextBox 4"/>
+          <p:cNvSpPr txBox="1"/>
+          <p:nvPr/>
+        </p:nvSpPr>
+        <p:spPr>
+          <a:xfrm>
+            <a:off x="6400800" y="1371600"/>
+            <a:ext cx="5029200" cy="4572000"/>
+          </a:xfrm>
+          <a:prstGeom prst="rect">
+            <a:avLst/>
+          </a:prstGeom>
+          <a:noFill/>
+        </p:spPr>
+        <p:txBody>
+          <a:bodyPr wrap="square">
+            <a:spAutoFit/>
+          </a:bodyPr>
+          <a:lstStyle/>
+          <a:p/>
+          <a:p>
+            <a:pPr>
+              <a:defRPr sz="1600" b="1">
+                <a:solidFill>
+                  <a:srgbClr val="FFFFFF"/>
+                </a:solidFill>
+              </a:defRPr>
+            </a:pPr>
+            <a:r>
+              <a:t>1. HSV가 RGB보다 실용적</a:t>
+            </a:r>
+          </a:p>
+          <a:p>
+            <a:pPr>
+              <a:defRPr sz="1400" b="0">
+                <a:solidFill>
+                  <a:srgbClr val="AAAAAA"/>
+                </a:solidFill>
+              </a:defRPr>
+            </a:pPr>
+            <a:r>
+              <a:t>   조명 변화에 강하고, 색상 개념에 가깝다</a:t>
+            </a:r>
+          </a:p>
+          <a:p>
+            <a:pPr>
+              <a:defRPr sz="600" b="0">
+                <a:solidFill>
+                  <a:srgbClr val="333333"/>
+                </a:solidFill>
+              </a:defRPr>
+            </a:pPr>
+          </a:p>
+          <a:p>
+            <a:pPr>
+              <a:defRPr sz="1600" b="1">
+                <a:solidFill>
+                  <a:srgbClr val="FFFFFF"/>
+                </a:solidFill>
+              </a:defRPr>
+            </a:pPr>
+            <a:r>
+              <a:t>2. cv2.bitwise_or vs + 연산자</a:t>
+            </a:r>
+          </a:p>
+          <a:p>
+            <a:pPr>
+              <a:defRPr sz="1400" b="0">
+                <a:solidFill>
+                  <a:srgbClr val="AAAAAA"/>
+                </a:solidFill>
+              </a:defRPr>
+            </a:pPr>
+            <a:r>
+              <a:t>   255+255=510 overflow. 비트연산이 정답.</a:t>
+            </a:r>
+          </a:p>
+          <a:p>
+            <a:pPr>
+              <a:defRPr sz="600" b="0">
+                <a:solidFill>
+                  <a:srgbClr val="333333"/>
+                </a:solidFill>
+              </a:defRPr>
+            </a:pPr>
+          </a:p>
+          <a:p>
+            <a:pPr>
+              <a:defRPr sz="1600" b="1">
+                <a:solidFill>
+                  <a:srgbClr val="FFFFFF"/>
+                </a:solidFill>
+              </a:defRPr>
+            </a:pPr>
+            <a:r>
+              <a:t>3. pandas EDA 먼저, 전처리는 그 다음</a:t>
+            </a:r>
+          </a:p>
+          <a:p>
+            <a:pPr>
+              <a:defRPr sz="1400" b="0">
+                <a:solidFill>
+                  <a:srgbClr val="AAAAAA"/>
+                </a:solidFill>
+              </a:defRPr>
+            </a:pPr>
+            <a:r>
+              <a:t>   데이터 분포 먼저 파악하고 전략 수립</a:t>
+            </a:r>
+          </a:p>
+          <a:p>
+            <a:pPr>
+              <a:defRPr sz="600" b="0">
+                <a:solidFill>
+                  <a:srgbClr val="333333"/>
+                </a:solidFill>
+              </a:defRPr>
+            </a:pPr>
+          </a:p>
+          <a:p>
+            <a:pPr>
+              <a:defRPr sz="1600" b="1">
+                <a:solidFill>
+                  <a:srgbClr val="FFFFFF"/>
+                </a:solidFill>
+              </a:defRPr>
+            </a:pPr>
+            <a:r>
+              <a:t>4. Git branch는 혼자여도 의미있다</a:t>
+            </a:r>
+          </a:p>
+          <a:p>
+            <a:pPr>
+              <a:defRPr sz="1400" b="0">
+                <a:solidFill>
+                  <a:srgbClr val="AAAAAA"/>
+                </a:solidFill>
+              </a:defRPr>
+            </a:pPr>
+            <a:r>
+              <a:t>   실수 복구 쉽고, 작업 단위가 명확</a:t>
+            </a:r>
+          </a:p>
+          <a:p>
+            <a:pPr>
+              <a:defRPr sz="600" b="0">
+                <a:solidFill>
+                  <a:srgbClr val="333333"/>
+                </a:solidFill>
+              </a:defRPr>
+            </a:pPr>
+          </a:p>
+          <a:p>
+            <a:pPr>
+              <a:defRPr sz="1600" b="1">
+                <a:solidFill>
+                  <a:srgbClr val="FFFFFF"/>
+                </a:solidFill>
+              </a:defRPr>
+            </a:pPr>
+            <a:r>
+              <a:t>5. OpenCV+NumPy만으로 충분</a:t>
+            </a:r>
+          </a:p>
+          <a:p>
+            <a:pPr>
+              <a:defRPr sz="1400" b="0">
+                <a:solidFill>
+                  <a:srgbClr val="AAAAAA"/>
+                </a:solidFill>
+              </a:defRPr>
+            </a:pPr>
+            <a:r>
+              <a:t>   추가 의존성 없이 기본 함수 조합으로 구현</a:t>
             </a:r>
           </a:p>
         </p:txBody>

</xml_diff>

<commit_message>
docs: regenerate PPT reflecting latest code changes
Co-authored-by: Cursor <cursoragent@cursor.com>
</commit_message>
<xml_diff>
--- a/presentation.pptx
+++ b/presentation.pptx
@@ -13,7 +13,6 @@
     <p:sldId id="261" r:id="rId12"/>
     <p:sldId id="262" r:id="rId13"/>
     <p:sldId id="263" r:id="rId14"/>
-    <p:sldId id="264" r:id="rId15"/>
   </p:sldIdLst>
   <p:sldSz cx="12191695" cy="6858000" type="screen4x3"/>
   <p:notesSz cx="6858000" cy="9144000"/>
@@ -4238,33 +4237,9 @@
           </a:p>
         </p:txBody>
       </p:sp>
-      <p:pic>
-        <p:nvPicPr>
-          <p:cNvPr id="6" name="Picture 5" descr="jsm0308-Bootcamp-CV.png"/>
-          <p:cNvPicPr>
-            <a:picLocks noChangeAspect="1"/>
-          </p:cNvPicPr>
-          <p:nvPr/>
-        </p:nvPicPr>
-        <p:blipFill>
-          <a:blip r:embed="rId2"/>
-          <a:stretch>
-            <a:fillRect/>
-          </a:stretch>
-        </p:blipFill>
-        <p:spPr>
-          <a:xfrm>
-            <a:off x="7132320" y="2011680"/>
-            <a:ext cx="4114800" cy="1903095"/>
-          </a:xfrm>
-          <a:prstGeom prst="rect">
-            <a:avLst/>
-          </a:prstGeom>
-        </p:spPr>
-      </p:pic>
-      <p:sp>
-        <p:nvSpPr>
-          <p:cNvPr id="7" name="TextBox 6"/>
+      <p:sp>
+        <p:nvSpPr>
+          <p:cNvPr id="6" name="TextBox 5"/>
           <p:cNvSpPr txBox="1"/>
           <p:nvPr/>
         </p:nvSpPr>
@@ -5288,186 +5263,6 @@
 </file>
 
 <file path=ppt/slides/slide8.xml><?xml version="1.0" encoding="utf-8"?>
-<p:sld xmlns:a="http://schemas.openxmlformats.org/drawingml/2006/main" xmlns:p="http://schemas.openxmlformats.org/presentationml/2006/main" xmlns:r="http://schemas.openxmlformats.org/officeDocument/2006/relationships">
-  <p:cSld>
-    <p:spTree>
-      <p:nvGrpSpPr>
-        <p:cNvPr id="1" name=""/>
-        <p:cNvGrpSpPr/>
-        <p:nvPr/>
-      </p:nvGrpSpPr>
-      <p:grpSpPr/>
-      <p:sp>
-        <p:nvSpPr>
-          <p:cNvPr id="2" name="Rectangle 1"/>
-          <p:cNvSpPr/>
-          <p:nvPr/>
-        </p:nvSpPr>
-        <p:spPr>
-          <a:xfrm>
-            <a:off x="0" y="0"/>
-            <a:ext cx="12191695" cy="1005840"/>
-          </a:xfrm>
-          <a:prstGeom prst="rect">
-            <a:avLst/>
-          </a:prstGeom>
-          <a:solidFill>
-            <a:srgbClr val="34495E"/>
-          </a:solidFill>
-          <a:ln>
-            <a:noFill/>
-          </a:ln>
-        </p:spPr>
-        <p:style>
-          <a:lnRef idx="1">
-            <a:schemeClr val="accent1"/>
-          </a:lnRef>
-          <a:fillRef idx="3">
-            <a:schemeClr val="accent1"/>
-          </a:fillRef>
-          <a:effectRef idx="2">
-            <a:schemeClr val="accent1"/>
-          </a:effectRef>
-          <a:fontRef idx="minor">
-            <a:schemeClr val="lt1"/>
-          </a:fontRef>
-        </p:style>
-        <p:txBody>
-          <a:bodyPr rtlCol="0" anchor="ctr"/>
-          <a:lstStyle/>
-          <a:p>
-            <a:pPr algn="ctr"/>
-          </a:p>
-        </p:txBody>
-      </p:sp>
-      <p:sp>
-        <p:nvSpPr>
-          <p:cNvPr id="3" name="TextBox 2"/>
-          <p:cNvSpPr txBox="1"/>
-          <p:nvPr/>
-        </p:nvSpPr>
-        <p:spPr>
-          <a:xfrm>
-            <a:off x="914400" y="137160"/>
-            <a:ext cx="10058400" cy="731520"/>
-          </a:xfrm>
-          <a:prstGeom prst="rect">
-            <a:avLst/>
-          </a:prstGeom>
-          <a:noFill/>
-        </p:spPr>
-        <p:txBody>
-          <a:bodyPr wrap="square">
-            <a:spAutoFit/>
-          </a:bodyPr>
-          <a:lstStyle/>
-          <a:p>
-            <a:pPr>
-              <a:defRPr sz="3200" b="1">
-                <a:solidFill>
-                  <a:srgbClr val="FFFFFF"/>
-                </a:solidFill>
-              </a:defRPr>
-            </a:pPr>
-            <a:r>
-              <a:t>GitHub Repository</a:t>
-            </a:r>
-          </a:p>
-        </p:txBody>
-      </p:sp>
-      <p:sp>
-        <p:nvSpPr>
-          <p:cNvPr id="4" name="TextBox 3"/>
-          <p:cNvSpPr txBox="1"/>
-          <p:nvPr/>
-        </p:nvSpPr>
-        <p:spPr>
-          <a:xfrm>
-            <a:off x="1371600" y="1371600"/>
-            <a:ext cx="9144000" cy="4114800"/>
-          </a:xfrm>
-          <a:prstGeom prst="rect">
-            <a:avLst/>
-          </a:prstGeom>
-          <a:noFill/>
-        </p:spPr>
-        <p:txBody>
-          <a:bodyPr wrap="square">
-            <a:spAutoFit/>
-          </a:bodyPr>
-          <a:lstStyle/>
-          <a:p/>
-          <a:p>
-            <a:pPr>
-              <a:defRPr sz="2000" b="1">
-                <a:solidFill>
-                  <a:srgbClr val="34495E"/>
-                </a:solidFill>
-              </a:defRPr>
-            </a:pPr>
-            <a:r>
-              <a:t>저장소: jsm0308/Bootcamp-CV</a:t>
-            </a:r>
-          </a:p>
-          <a:p>
-            <a:pPr>
-              <a:defRPr sz="1600" b="0">
-                <a:solidFill>
-                  <a:srgbClr val="555555"/>
-                </a:solidFill>
-              </a:defRPr>
-            </a:pPr>
-            <a:r>
-              <a:t>git/  → 핵심 과제: red.py (빨간색 검출)</a:t>
-            </a:r>
-          </a:p>
-          <a:p>
-            <a:pPr>
-              <a:defRPr sz="1600" b="0">
-                <a:solidFill>
-                  <a:srgbClr val="555555"/>
-                </a:solidFill>
-              </a:defRPr>
-            </a:pPr>
-            <a:r>
-              <a:t>huggingface/ → 추가 과제: dataset.py, image_preprocessing.py</a:t>
-            </a:r>
-          </a:p>
-        </p:txBody>
-      </p:sp>
-      <p:pic>
-        <p:nvPicPr>
-          <p:cNvPr id="5" name="Picture 4" descr="jsm0308-Bootcamp-CV.png"/>
-          <p:cNvPicPr>
-            <a:picLocks noChangeAspect="1"/>
-          </p:cNvPicPr>
-          <p:nvPr/>
-        </p:nvPicPr>
-        <p:blipFill>
-          <a:blip r:embed="rId2"/>
-          <a:stretch>
-            <a:fillRect/>
-          </a:stretch>
-        </p:blipFill>
-        <p:spPr>
-          <a:xfrm>
-            <a:off x="6858000" y="1645920"/>
-            <a:ext cx="4572000" cy="2114550"/>
-          </a:xfrm>
-          <a:prstGeom prst="rect">
-            <a:avLst/>
-          </a:prstGeom>
-        </p:spPr>
-      </p:pic>
-    </p:spTree>
-  </p:cSld>
-  <p:clrMapOvr>
-    <a:masterClrMapping/>
-  </p:clrMapOvr>
-</p:sld>
-</file>
-
-<file path=ppt/slides/slide9.xml><?xml version="1.0" encoding="utf-8"?>
 <p:sld xmlns:a="http://schemas.openxmlformats.org/drawingml/2006/main" xmlns:p="http://schemas.openxmlformats.org/presentationml/2006/main" xmlns:r="http://schemas.openxmlformats.org/officeDocument/2006/relationships">
   <p:cSld>
     <p:bg>

</xml_diff>